<commit_message>
Edit class 01 slides
</commit_message>
<xml_diff>
--- a/slides/1_mlflow/class01_slides.pptx
+++ b/slides/1_mlflow/class01_slides.pptx
@@ -5,7 +5,7 @@
     <p:sldMasterId id="2147483660" r:id="rId1"/>
   </p:sldMasterIdLst>
   <p:notesMasterIdLst>
-    <p:notesMasterId r:id="rId23"/>
+    <p:notesMasterId r:id="rId20"/>
   </p:notesMasterIdLst>
   <p:sldIdLst>
     <p:sldId id="256" r:id="rId2"/>
@@ -19,16 +19,13 @@
     <p:sldId id="290" r:id="rId10"/>
     <p:sldId id="293" r:id="rId11"/>
     <p:sldId id="291" r:id="rId12"/>
-    <p:sldId id="294" r:id="rId13"/>
-    <p:sldId id="283" r:id="rId14"/>
-    <p:sldId id="258" r:id="rId15"/>
-    <p:sldId id="272" r:id="rId16"/>
-    <p:sldId id="269" r:id="rId17"/>
-    <p:sldId id="273" r:id="rId18"/>
-    <p:sldId id="270" r:id="rId19"/>
-    <p:sldId id="296" r:id="rId20"/>
-    <p:sldId id="297" r:id="rId21"/>
-    <p:sldId id="399" r:id="rId22"/>
+    <p:sldId id="283" r:id="rId13"/>
+    <p:sldId id="258" r:id="rId14"/>
+    <p:sldId id="272" r:id="rId15"/>
+    <p:sldId id="269" r:id="rId16"/>
+    <p:sldId id="270" r:id="rId17"/>
+    <p:sldId id="297" r:id="rId18"/>
+    <p:sldId id="399" r:id="rId19"/>
   </p:sldIdLst>
   <p:sldSz cx="9144000" cy="5143500" type="screen16x9"/>
   <p:notesSz cx="6858000" cy="9144000"/>
@@ -13177,46 +13174,7 @@
       </p:grpSpPr>
       <p:sp>
         <p:nvSpPr>
-          <p:cNvPr id="2" name="Titre 1"/>
-          <p:cNvSpPr>
-            <a:spLocks noGrp="1"/>
-          </p:cNvSpPr>
-          <p:nvPr>
-            <p:ph type="title"/>
-          </p:nvPr>
-        </p:nvSpPr>
-        <p:spPr/>
-        <p:txBody>
-          <a:bodyPr/>
-          <a:lstStyle/>
-          <a:p>
-            <a:r>
-              <a:rPr lang="fr-FR" dirty="0" err="1"/>
-              <a:t>MLOps</a:t>
-            </a:r>
-            <a:r>
-              <a:rPr lang="fr-FR" dirty="0"/>
-              <a:t> </a:t>
-            </a:r>
-            <a:r>
-              <a:rPr lang="fr-FR" dirty="0" err="1"/>
-              <a:t>tools</a:t>
-            </a:r>
-            <a:r>
-              <a:rPr lang="fr-FR" dirty="0"/>
-              <a:t> </a:t>
-            </a:r>
-            <a:r>
-              <a:rPr lang="fr-FR" dirty="0" err="1"/>
-              <a:t>landscape</a:t>
-            </a:r>
-            <a:endParaRPr lang="fr-FR" dirty="0"/>
-          </a:p>
-        </p:txBody>
-      </p:sp>
-      <p:sp>
-        <p:nvSpPr>
-          <p:cNvPr id="4" name="Espace réservé du numéro de diapositive 3"/>
+          <p:cNvPr id="2" name="Espace réservé du numéro de diapositive 1"/>
           <p:cNvSpPr>
             <a:spLocks noGrp="1"/>
           </p:cNvSpPr>
@@ -13238,134 +13196,6 @@
                 <a:defRPr/>
               </a:pPr>
               <a:t>12</a:t>
-            </a:fld>
-            <a:endParaRPr lang="fr-FR" dirty="0"/>
-          </a:p>
-        </p:txBody>
-      </p:sp>
-      <p:pic>
-        <p:nvPicPr>
-          <p:cNvPr id="11266" name="Picture 2" descr="https://blogs.sas.com/content/subconsciousmusings/files/2024/07/Untitled-picture-1024x646.png"/>
-          <p:cNvPicPr>
-            <a:picLocks noChangeAspect="1" noChangeArrowheads="1"/>
-          </p:cNvPicPr>
-          <p:nvPr/>
-        </p:nvPicPr>
-        <p:blipFill>
-          <a:blip r:embed="rId2" cstate="screen">
-            <a:extLst>
-              <a:ext uri="{28A0092B-C50C-407E-A947-70E740481C1C}">
-                <a14:useLocalDpi xmlns:a14="http://schemas.microsoft.com/office/drawing/2010/main" val="0"/>
-              </a:ext>
-            </a:extLst>
-          </a:blip>
-          <a:srcRect/>
-          <a:stretch>
-            <a:fillRect/>
-          </a:stretch>
-        </p:blipFill>
-        <p:spPr bwMode="auto">
-          <a:xfrm>
-            <a:off x="1811628" y="939020"/>
-            <a:ext cx="5795476" cy="3656131"/>
-          </a:xfrm>
-          <a:prstGeom prst="rect">
-            <a:avLst/>
-          </a:prstGeom>
-          <a:noFill/>
-          <a:extLst>
-            <a:ext uri="{909E8E84-426E-40DD-AFC4-6F175D3DCCD1}">
-              <a14:hiddenFill xmlns:a14="http://schemas.microsoft.com/office/drawing/2010/main">
-                <a:solidFill>
-                  <a:srgbClr val="FFFFFF"/>
-                </a:solidFill>
-              </a14:hiddenFill>
-            </a:ext>
-          </a:extLst>
-        </p:spPr>
-      </p:pic>
-      <p:sp>
-        <p:nvSpPr>
-          <p:cNvPr id="7" name="Espace réservé du pied de page 4"/>
-          <p:cNvSpPr>
-            <a:spLocks noGrp="1"/>
-          </p:cNvSpPr>
-          <p:nvPr>
-            <p:ph type="ftr" sz="quarter" idx="3"/>
-          </p:nvPr>
-        </p:nvSpPr>
-        <p:spPr>
-          <a:xfrm>
-            <a:off x="383931" y="4805046"/>
-            <a:ext cx="4254012" cy="273844"/>
-          </a:xfrm>
-        </p:spPr>
-        <p:txBody>
-          <a:bodyPr/>
-          <a:lstStyle/>
-          <a:p>
-            <a:r>
-              <a:rPr lang="en-US" dirty="0"/>
-              <a:t>2026 | ©HeadMind Partners AI &amp; Blockchain</a:t>
-            </a:r>
-            <a:endParaRPr lang="fr-FR" dirty="0"/>
-          </a:p>
-        </p:txBody>
-      </p:sp>
-    </p:spTree>
-    <p:extLst>
-      <p:ext uri="{BB962C8B-B14F-4D97-AF65-F5344CB8AC3E}">
-        <p14:creationId xmlns:p14="http://schemas.microsoft.com/office/powerpoint/2010/main" val="2219912252"/>
-      </p:ext>
-    </p:extLst>
-  </p:cSld>
-  <p:clrMapOvr>
-    <a:masterClrMapping/>
-  </p:clrMapOvr>
-</p:sld>
-</file>
-
-<file path=ppt/slides/slide13.xml><?xml version="1.0" encoding="utf-8"?>
-<p:sld xmlns:a="http://schemas.openxmlformats.org/drawingml/2006/main" xmlns:r="http://schemas.openxmlformats.org/officeDocument/2006/relationships" xmlns:p="http://schemas.openxmlformats.org/presentationml/2006/main">
-  <p:cSld>
-    <p:spTree>
-      <p:nvGrpSpPr>
-        <p:cNvPr id="1" name=""/>
-        <p:cNvGrpSpPr/>
-        <p:nvPr/>
-      </p:nvGrpSpPr>
-      <p:grpSpPr>
-        <a:xfrm>
-          <a:off x="0" y="0"/>
-          <a:ext cx="0" cy="0"/>
-          <a:chOff x="0" y="0"/>
-          <a:chExt cx="0" cy="0"/>
-        </a:xfrm>
-      </p:grpSpPr>
-      <p:sp>
-        <p:nvSpPr>
-          <p:cNvPr id="2" name="Espace réservé du numéro de diapositive 1"/>
-          <p:cNvSpPr>
-            <a:spLocks noGrp="1"/>
-          </p:cNvSpPr>
-          <p:nvPr>
-            <p:ph type="sldNum" sz="quarter" idx="4"/>
-          </p:nvPr>
-        </p:nvSpPr>
-        <p:spPr/>
-        <p:txBody>
-          <a:bodyPr/>
-          <a:lstStyle/>
-          <a:p>
-            <a:pPr>
-              <a:defRPr/>
-            </a:pPr>
-            <a:fld id="{F4FEB08F-923E-484A-9FC5-0AA7BDA29BD6}" type="slidenum">
-              <a:rPr lang="fr-FR" smtClean="0"/>
-              <a:pPr>
-                <a:defRPr/>
-              </a:pPr>
-              <a:t>13</a:t>
             </a:fld>
             <a:endParaRPr lang="fr-FR" dirty="0"/>
           </a:p>
@@ -13478,7 +13308,7 @@
 </p:sld>
 </file>
 
-<file path=ppt/slides/slide14.xml><?xml version="1.0" encoding="utf-8"?>
+<file path=ppt/slides/slide13.xml><?xml version="1.0" encoding="utf-8"?>
 <p:sld xmlns:a="http://schemas.openxmlformats.org/drawingml/2006/main" xmlns:r="http://schemas.openxmlformats.org/officeDocument/2006/relationships" xmlns:p="http://schemas.openxmlformats.org/presentationml/2006/main">
   <p:cSld>
     <p:spTree>
@@ -13573,7 +13403,7 @@
               <a:pPr>
                 <a:defRPr/>
               </a:pPr>
-              <a:t>14</a:t>
+              <a:t>13</a:t>
             </a:fld>
             <a:endParaRPr lang="fr-FR" dirty="0"/>
           </a:p>
@@ -13758,7 +13588,7 @@
 </p:sld>
 </file>
 
-<file path=ppt/slides/slide15.xml><?xml version="1.0" encoding="utf-8"?>
+<file path=ppt/slides/slide14.xml><?xml version="1.0" encoding="utf-8"?>
 <p:sld xmlns:a="http://schemas.openxmlformats.org/drawingml/2006/main" xmlns:r="http://schemas.openxmlformats.org/officeDocument/2006/relationships" xmlns:p="http://schemas.openxmlformats.org/presentationml/2006/main">
   <p:cSld>
     <p:spTree>
@@ -13950,7 +13780,7 @@
               <a:pPr>
                 <a:defRPr/>
               </a:pPr>
-              <a:t>15</a:t>
+              <a:t>14</a:t>
             </a:fld>
             <a:endParaRPr lang="fr-FR" dirty="0"/>
           </a:p>
@@ -14229,7 +14059,7 @@
 </p:sld>
 </file>
 
-<file path=ppt/slides/slide16.xml><?xml version="1.0" encoding="utf-8"?>
+<file path=ppt/slides/slide15.xml><?xml version="1.0" encoding="utf-8"?>
 <p:sld xmlns:a="http://schemas.openxmlformats.org/drawingml/2006/main" xmlns:r="http://schemas.openxmlformats.org/officeDocument/2006/relationships" xmlns:p="http://schemas.openxmlformats.org/presentationml/2006/main">
   <p:cSld>
     <p:spTree>
@@ -14340,7 +14170,7 @@
               <a:pPr>
                 <a:defRPr/>
               </a:pPr>
-              <a:t>16</a:t>
+              <a:t>15</a:t>
             </a:fld>
             <a:endParaRPr lang="fr-FR" dirty="0"/>
           </a:p>
@@ -14882,6 +14712,770 @@
     <p:extLst>
       <p:ext uri="{BB962C8B-B14F-4D97-AF65-F5344CB8AC3E}">
         <p14:creationId xmlns:p14="http://schemas.microsoft.com/office/powerpoint/2010/main" val="2532761736"/>
+      </p:ext>
+    </p:extLst>
+  </p:cSld>
+  <p:clrMapOvr>
+    <a:masterClrMapping/>
+  </p:clrMapOvr>
+</p:sld>
+</file>
+
+<file path=ppt/slides/slide16.xml><?xml version="1.0" encoding="utf-8"?>
+<p:sld xmlns:a="http://schemas.openxmlformats.org/drawingml/2006/main" xmlns:r="http://schemas.openxmlformats.org/officeDocument/2006/relationships" xmlns:p="http://schemas.openxmlformats.org/presentationml/2006/main">
+  <p:cSld>
+    <p:spTree>
+      <p:nvGrpSpPr>
+        <p:cNvPr id="1" name=""/>
+        <p:cNvGrpSpPr/>
+        <p:nvPr/>
+      </p:nvGrpSpPr>
+      <p:grpSpPr>
+        <a:xfrm>
+          <a:off x="0" y="0"/>
+          <a:ext cx="0" cy="0"/>
+          <a:chOff x="0" y="0"/>
+          <a:chExt cx="0" cy="0"/>
+        </a:xfrm>
+      </p:grpSpPr>
+      <p:sp>
+        <p:nvSpPr>
+          <p:cNvPr id="2" name="Titre 1"/>
+          <p:cNvSpPr>
+            <a:spLocks noGrp="1"/>
+          </p:cNvSpPr>
+          <p:nvPr>
+            <p:ph type="title"/>
+          </p:nvPr>
+        </p:nvSpPr>
+        <p:spPr/>
+        <p:txBody>
+          <a:bodyPr/>
+          <a:lstStyle/>
+          <a:p>
+            <a:r>
+              <a:rPr lang="fr-FR" dirty="0" err="1"/>
+              <a:t>When</a:t>
+            </a:r>
+            <a:r>
+              <a:rPr lang="fr-FR" dirty="0"/>
+              <a:t> to use MLFlow ?</a:t>
+            </a:r>
+          </a:p>
+        </p:txBody>
+      </p:sp>
+      <p:sp>
+        <p:nvSpPr>
+          <p:cNvPr id="4" name="Espace réservé du numéro de diapositive 3"/>
+          <p:cNvSpPr>
+            <a:spLocks noGrp="1"/>
+          </p:cNvSpPr>
+          <p:nvPr>
+            <p:ph type="sldNum" sz="quarter" idx="4"/>
+          </p:nvPr>
+        </p:nvSpPr>
+        <p:spPr/>
+        <p:txBody>
+          <a:bodyPr/>
+          <a:lstStyle/>
+          <a:p>
+            <a:pPr>
+              <a:defRPr/>
+            </a:pPr>
+            <a:fld id="{F4FEB08F-923E-484A-9FC5-0AA7BDA29BD6}" type="slidenum">
+              <a:rPr lang="fr-FR" smtClean="0"/>
+              <a:pPr>
+                <a:defRPr/>
+              </a:pPr>
+              <a:t>16</a:t>
+            </a:fld>
+            <a:endParaRPr lang="fr-FR" dirty="0"/>
+          </a:p>
+        </p:txBody>
+      </p:sp>
+      <p:sp>
+        <p:nvSpPr>
+          <p:cNvPr id="6" name="Espace réservé du pied de page 4"/>
+          <p:cNvSpPr>
+            <a:spLocks noGrp="1"/>
+          </p:cNvSpPr>
+          <p:nvPr>
+            <p:ph type="ftr" sz="quarter" idx="3"/>
+          </p:nvPr>
+        </p:nvSpPr>
+        <p:spPr>
+          <a:xfrm>
+            <a:off x="383931" y="4805046"/>
+            <a:ext cx="4254012" cy="273844"/>
+          </a:xfrm>
+        </p:spPr>
+        <p:txBody>
+          <a:bodyPr/>
+          <a:lstStyle/>
+          <a:p>
+            <a:r>
+              <a:rPr lang="en-US" dirty="0"/>
+              <a:t>2026 | ©HeadMind Partners AI &amp; Blockchain</a:t>
+            </a:r>
+            <a:endParaRPr lang="fr-FR" dirty="0"/>
+          </a:p>
+        </p:txBody>
+      </p:sp>
+      <p:sp>
+        <p:nvSpPr>
+          <p:cNvPr id="8" name="Shape 6">
+            <a:extLst>
+              <a:ext uri="{FF2B5EF4-FFF2-40B4-BE49-F238E27FC236}">
+                <a16:creationId xmlns:a16="http://schemas.microsoft.com/office/drawing/2014/main" id="{D1127455-F0F5-76B1-21C5-5B32C70D5CE9}"/>
+              </a:ext>
+            </a:extLst>
+          </p:cNvPr>
+          <p:cNvSpPr/>
+          <p:nvPr/>
+        </p:nvSpPr>
+        <p:spPr>
+          <a:xfrm>
+            <a:off x="548640" y="1173480"/>
+            <a:ext cx="8046720" cy="960120"/>
+          </a:xfrm>
+          <a:prstGeom prst="rect">
+            <a:avLst/>
+          </a:prstGeom>
+          <a:solidFill>
+            <a:srgbClr val="FFFFFF"/>
+          </a:solidFill>
+          <a:ln/>
+          <a:effectLst>
+            <a:outerShdw blurRad="101600" dist="38100" dir="8100000" algn="bl" rotWithShape="0">
+              <a:srgbClr val="000000">
+                <a:alpha val="10000"/>
+              </a:srgbClr>
+            </a:outerShdw>
+          </a:effectLst>
+        </p:spPr>
+      </p:sp>
+      <p:sp>
+        <p:nvSpPr>
+          <p:cNvPr id="9" name="Shape 7">
+            <a:extLst>
+              <a:ext uri="{FF2B5EF4-FFF2-40B4-BE49-F238E27FC236}">
+                <a16:creationId xmlns:a16="http://schemas.microsoft.com/office/drawing/2014/main" id="{1BDB26B5-144F-D788-3E32-90BED80C807B}"/>
+              </a:ext>
+            </a:extLst>
+          </p:cNvPr>
+          <p:cNvSpPr/>
+          <p:nvPr/>
+        </p:nvSpPr>
+        <p:spPr>
+          <a:xfrm>
+            <a:off x="548640" y="1173480"/>
+            <a:ext cx="54864" cy="960120"/>
+          </a:xfrm>
+          <a:prstGeom prst="rect">
+            <a:avLst/>
+          </a:prstGeom>
+          <a:solidFill>
+            <a:srgbClr val="0EA5E9"/>
+          </a:solidFill>
+          <a:ln/>
+        </p:spPr>
+      </p:sp>
+      <p:sp>
+        <p:nvSpPr>
+          <p:cNvPr id="10" name="Shape 8">
+            <a:extLst>
+              <a:ext uri="{FF2B5EF4-FFF2-40B4-BE49-F238E27FC236}">
+                <a16:creationId xmlns:a16="http://schemas.microsoft.com/office/drawing/2014/main" id="{FB72635D-F412-6FDF-8722-3421F072F0B8}"/>
+              </a:ext>
+            </a:extLst>
+          </p:cNvPr>
+          <p:cNvSpPr/>
+          <p:nvPr/>
+        </p:nvSpPr>
+        <p:spPr>
+          <a:xfrm>
+            <a:off x="777240" y="1402080"/>
+            <a:ext cx="411480" cy="411480"/>
+          </a:xfrm>
+          <a:prstGeom prst="ellipse">
+            <a:avLst/>
+          </a:prstGeom>
+          <a:solidFill>
+            <a:srgbClr val="0EA5E9"/>
+          </a:solidFill>
+          <a:ln/>
+        </p:spPr>
+      </p:sp>
+      <p:sp>
+        <p:nvSpPr>
+          <p:cNvPr id="11" name="Text 9">
+            <a:extLst>
+              <a:ext uri="{FF2B5EF4-FFF2-40B4-BE49-F238E27FC236}">
+                <a16:creationId xmlns:a16="http://schemas.microsoft.com/office/drawing/2014/main" id="{F3B5F2CE-50FA-8D7D-5536-E74CD6D63FCC}"/>
+              </a:ext>
+            </a:extLst>
+          </p:cNvPr>
+          <p:cNvSpPr/>
+          <p:nvPr/>
+        </p:nvSpPr>
+        <p:spPr>
+          <a:xfrm>
+            <a:off x="777240" y="1402080"/>
+            <a:ext cx="411480" cy="411480"/>
+          </a:xfrm>
+          <a:prstGeom prst="rect">
+            <a:avLst/>
+          </a:prstGeom>
+          <a:noFill/>
+          <a:ln/>
+        </p:spPr>
+        <p:txBody>
+          <a:bodyPr wrap="square" lIns="0" tIns="0" rIns="0" bIns="0" rtlCol="0" anchor="ctr"/>
+          <a:lstStyle/>
+          <a:p>
+            <a:pPr marL="0" indent="0" algn="ctr">
+              <a:buNone/>
+            </a:pPr>
+            <a:r>
+              <a:rPr lang="en-US" sz="1600" b="1" dirty="0">
+                <a:solidFill>
+                  <a:srgbClr val="FFFFFF"/>
+                </a:solidFill>
+                <a:ea typeface="Trebuchet MS" pitchFamily="34" charset="-122"/>
+                <a:cs typeface="Trebuchet MS" pitchFamily="34" charset="-120"/>
+              </a:rPr>
+              <a:t>1</a:t>
+            </a:r>
+            <a:endParaRPr lang="en-US" sz="1600" dirty="0"/>
+          </a:p>
+        </p:txBody>
+      </p:sp>
+      <p:sp>
+        <p:nvSpPr>
+          <p:cNvPr id="12" name="Text 10">
+            <a:extLst>
+              <a:ext uri="{FF2B5EF4-FFF2-40B4-BE49-F238E27FC236}">
+                <a16:creationId xmlns:a16="http://schemas.microsoft.com/office/drawing/2014/main" id="{71C63F7C-C823-D0FF-7294-A61344FE1ABD}"/>
+              </a:ext>
+            </a:extLst>
+          </p:cNvPr>
+          <p:cNvSpPr/>
+          <p:nvPr/>
+        </p:nvSpPr>
+        <p:spPr>
+          <a:xfrm>
+            <a:off x="1371600" y="1283208"/>
+            <a:ext cx="2743200" cy="320040"/>
+          </a:xfrm>
+          <a:prstGeom prst="rect">
+            <a:avLst/>
+          </a:prstGeom>
+          <a:noFill/>
+          <a:ln/>
+        </p:spPr>
+        <p:txBody>
+          <a:bodyPr wrap="square" lIns="0" tIns="0" rIns="0" bIns="0" rtlCol="0" anchor="ctr"/>
+          <a:lstStyle/>
+          <a:p>
+            <a:pPr marL="0" indent="0">
+              <a:buNone/>
+            </a:pPr>
+            <a:r>
+              <a:rPr lang="en-US" sz="1500" b="1" dirty="0">
+                <a:solidFill>
+                  <a:srgbClr val="0F172A"/>
+                </a:solidFill>
+                <a:ea typeface="Trebuchet MS" pitchFamily="34" charset="-122"/>
+                <a:cs typeface="Trebuchet MS" pitchFamily="34" charset="-120"/>
+              </a:rPr>
+              <a:t>Solo projects (local)</a:t>
+            </a:r>
+            <a:endParaRPr lang="en-US" sz="1500" dirty="0"/>
+          </a:p>
+        </p:txBody>
+      </p:sp>
+      <p:sp>
+        <p:nvSpPr>
+          <p:cNvPr id="13" name="Text 11">
+            <a:extLst>
+              <a:ext uri="{FF2B5EF4-FFF2-40B4-BE49-F238E27FC236}">
+                <a16:creationId xmlns:a16="http://schemas.microsoft.com/office/drawing/2014/main" id="{633FDE7A-8BD0-BB46-068A-9873457F828F}"/>
+              </a:ext>
+            </a:extLst>
+          </p:cNvPr>
+          <p:cNvSpPr/>
+          <p:nvPr/>
+        </p:nvSpPr>
+        <p:spPr>
+          <a:xfrm>
+            <a:off x="1371600" y="1612392"/>
+            <a:ext cx="6949440" cy="457200"/>
+          </a:xfrm>
+          <a:prstGeom prst="rect">
+            <a:avLst/>
+          </a:prstGeom>
+          <a:noFill/>
+          <a:ln/>
+        </p:spPr>
+        <p:txBody>
+          <a:bodyPr wrap="square" lIns="0" tIns="0" rIns="0" bIns="0" rtlCol="0" anchor="ctr"/>
+          <a:lstStyle/>
+          <a:p>
+            <a:pPr marL="0" indent="0">
+              <a:buNone/>
+            </a:pPr>
+            <a:r>
+              <a:rPr lang="en-US" sz="1200" dirty="0">
+                <a:solidFill>
+                  <a:srgbClr val="475569"/>
+                </a:solidFill>
+                <a:ea typeface="Calibri" pitchFamily="34" charset="-122"/>
+                <a:cs typeface="Calibri" pitchFamily="34" charset="-120"/>
+              </a:rPr>
+              <a:t>When training one or more ML models on your own machine. MLflow is lightweight — track experiment results without heavy dependencies.</a:t>
+            </a:r>
+            <a:endParaRPr lang="en-US" sz="1200" dirty="0"/>
+          </a:p>
+        </p:txBody>
+      </p:sp>
+      <p:sp>
+        <p:nvSpPr>
+          <p:cNvPr id="14" name="Shape 12">
+            <a:extLst>
+              <a:ext uri="{FF2B5EF4-FFF2-40B4-BE49-F238E27FC236}">
+                <a16:creationId xmlns:a16="http://schemas.microsoft.com/office/drawing/2014/main" id="{0F582C3A-4AA6-490B-2FEA-F595CE85C6BB}"/>
+              </a:ext>
+            </a:extLst>
+          </p:cNvPr>
+          <p:cNvSpPr/>
+          <p:nvPr/>
+        </p:nvSpPr>
+        <p:spPr>
+          <a:xfrm>
+            <a:off x="548640" y="2316480"/>
+            <a:ext cx="8046720" cy="960120"/>
+          </a:xfrm>
+          <a:prstGeom prst="rect">
+            <a:avLst/>
+          </a:prstGeom>
+          <a:solidFill>
+            <a:srgbClr val="FFFFFF"/>
+          </a:solidFill>
+          <a:ln/>
+          <a:effectLst>
+            <a:outerShdw blurRad="101600" dist="38100" dir="8100000" algn="bl" rotWithShape="0">
+              <a:srgbClr val="000000">
+                <a:alpha val="10000"/>
+              </a:srgbClr>
+            </a:outerShdw>
+          </a:effectLst>
+        </p:spPr>
+      </p:sp>
+      <p:sp>
+        <p:nvSpPr>
+          <p:cNvPr id="15" name="Shape 13">
+            <a:extLst>
+              <a:ext uri="{FF2B5EF4-FFF2-40B4-BE49-F238E27FC236}">
+                <a16:creationId xmlns:a16="http://schemas.microsoft.com/office/drawing/2014/main" id="{8F7A1C67-CA40-FC40-4125-9268BBD42A68}"/>
+              </a:ext>
+            </a:extLst>
+          </p:cNvPr>
+          <p:cNvSpPr/>
+          <p:nvPr/>
+        </p:nvSpPr>
+        <p:spPr>
+          <a:xfrm>
+            <a:off x="548640" y="2316480"/>
+            <a:ext cx="54864" cy="960120"/>
+          </a:xfrm>
+          <a:prstGeom prst="rect">
+            <a:avLst/>
+          </a:prstGeom>
+          <a:solidFill>
+            <a:srgbClr val="10B981"/>
+          </a:solidFill>
+          <a:ln/>
+        </p:spPr>
+      </p:sp>
+      <p:sp>
+        <p:nvSpPr>
+          <p:cNvPr id="16" name="Shape 14">
+            <a:extLst>
+              <a:ext uri="{FF2B5EF4-FFF2-40B4-BE49-F238E27FC236}">
+                <a16:creationId xmlns:a16="http://schemas.microsoft.com/office/drawing/2014/main" id="{A91219F6-49D2-0B76-E4DB-C96001EB315E}"/>
+              </a:ext>
+            </a:extLst>
+          </p:cNvPr>
+          <p:cNvSpPr/>
+          <p:nvPr/>
+        </p:nvSpPr>
+        <p:spPr>
+          <a:xfrm>
+            <a:off x="777240" y="2545080"/>
+            <a:ext cx="411480" cy="411480"/>
+          </a:xfrm>
+          <a:prstGeom prst="ellipse">
+            <a:avLst/>
+          </a:prstGeom>
+          <a:solidFill>
+            <a:srgbClr val="10B981"/>
+          </a:solidFill>
+          <a:ln/>
+        </p:spPr>
+      </p:sp>
+      <p:sp>
+        <p:nvSpPr>
+          <p:cNvPr id="17" name="Text 15">
+            <a:extLst>
+              <a:ext uri="{FF2B5EF4-FFF2-40B4-BE49-F238E27FC236}">
+                <a16:creationId xmlns:a16="http://schemas.microsoft.com/office/drawing/2014/main" id="{A7BBD760-1773-5E36-2057-51C384A94DF9}"/>
+              </a:ext>
+            </a:extLst>
+          </p:cNvPr>
+          <p:cNvSpPr/>
+          <p:nvPr/>
+        </p:nvSpPr>
+        <p:spPr>
+          <a:xfrm>
+            <a:off x="777240" y="2545080"/>
+            <a:ext cx="411480" cy="411480"/>
+          </a:xfrm>
+          <a:prstGeom prst="rect">
+            <a:avLst/>
+          </a:prstGeom>
+          <a:noFill/>
+          <a:ln/>
+        </p:spPr>
+        <p:txBody>
+          <a:bodyPr wrap="square" lIns="0" tIns="0" rIns="0" bIns="0" rtlCol="0" anchor="ctr"/>
+          <a:lstStyle/>
+          <a:p>
+            <a:pPr marL="0" indent="0" algn="ctr">
+              <a:buNone/>
+            </a:pPr>
+            <a:r>
+              <a:rPr lang="en-US" sz="1600" b="1" dirty="0">
+                <a:solidFill>
+                  <a:srgbClr val="FFFFFF"/>
+                </a:solidFill>
+                <a:ea typeface="Trebuchet MS" pitchFamily="34" charset="-122"/>
+                <a:cs typeface="Trebuchet MS" pitchFamily="34" charset="-120"/>
+              </a:rPr>
+              <a:t>2</a:t>
+            </a:r>
+            <a:endParaRPr lang="en-US" sz="1600" dirty="0"/>
+          </a:p>
+        </p:txBody>
+      </p:sp>
+      <p:sp>
+        <p:nvSpPr>
+          <p:cNvPr id="18" name="Text 16">
+            <a:extLst>
+              <a:ext uri="{FF2B5EF4-FFF2-40B4-BE49-F238E27FC236}">
+                <a16:creationId xmlns:a16="http://schemas.microsoft.com/office/drawing/2014/main" id="{5D93ABD8-00BF-7AA6-EBFD-F91C10AF67CD}"/>
+              </a:ext>
+            </a:extLst>
+          </p:cNvPr>
+          <p:cNvSpPr/>
+          <p:nvPr/>
+        </p:nvSpPr>
+        <p:spPr>
+          <a:xfrm>
+            <a:off x="1371600" y="2426208"/>
+            <a:ext cx="2743200" cy="320040"/>
+          </a:xfrm>
+          <a:prstGeom prst="rect">
+            <a:avLst/>
+          </a:prstGeom>
+          <a:noFill/>
+          <a:ln/>
+        </p:spPr>
+        <p:txBody>
+          <a:bodyPr wrap="square" lIns="0" tIns="0" rIns="0" bIns="0" rtlCol="0" anchor="ctr"/>
+          <a:lstStyle/>
+          <a:p>
+            <a:pPr marL="0" indent="0">
+              <a:buNone/>
+            </a:pPr>
+            <a:r>
+              <a:rPr lang="en-US" sz="1500" b="1" dirty="0">
+                <a:solidFill>
+                  <a:srgbClr val="0F172A"/>
+                </a:solidFill>
+                <a:ea typeface="Trebuchet MS" pitchFamily="34" charset="-122"/>
+                <a:cs typeface="Trebuchet MS" pitchFamily="34" charset="-120"/>
+              </a:rPr>
+              <a:t>Team projects</a:t>
+            </a:r>
+            <a:endParaRPr lang="en-US" sz="1500" dirty="0"/>
+          </a:p>
+        </p:txBody>
+      </p:sp>
+      <p:sp>
+        <p:nvSpPr>
+          <p:cNvPr id="19" name="Text 17">
+            <a:extLst>
+              <a:ext uri="{FF2B5EF4-FFF2-40B4-BE49-F238E27FC236}">
+                <a16:creationId xmlns:a16="http://schemas.microsoft.com/office/drawing/2014/main" id="{DB68912D-AF72-769B-CBB8-717B5313D398}"/>
+              </a:ext>
+            </a:extLst>
+          </p:cNvPr>
+          <p:cNvSpPr/>
+          <p:nvPr/>
+        </p:nvSpPr>
+        <p:spPr>
+          <a:xfrm>
+            <a:off x="1371600" y="2755392"/>
+            <a:ext cx="6949440" cy="457200"/>
+          </a:xfrm>
+          <a:prstGeom prst="rect">
+            <a:avLst/>
+          </a:prstGeom>
+          <a:noFill/>
+          <a:ln/>
+        </p:spPr>
+        <p:txBody>
+          <a:bodyPr wrap="square" lIns="0" tIns="0" rIns="0" bIns="0" rtlCol="0" anchor="ctr"/>
+          <a:lstStyle/>
+          <a:p>
+            <a:pPr marL="0" indent="0">
+              <a:buNone/>
+            </a:pPr>
+            <a:r>
+              <a:rPr lang="en-US" sz="1200" dirty="0">
+                <a:solidFill>
+                  <a:srgbClr val="475569"/>
+                </a:solidFill>
+                <a:ea typeface="Calibri" pitchFamily="34" charset="-122"/>
+                <a:cs typeface="Calibri" pitchFamily="34" charset="-120"/>
+              </a:rPr>
+              <a:t>Share hyperparameters, metrics, and KPIs on the same model across your team. Everyone sees the same experiment history.</a:t>
+            </a:r>
+            <a:endParaRPr lang="en-US" sz="1200" dirty="0"/>
+          </a:p>
+        </p:txBody>
+      </p:sp>
+      <p:sp>
+        <p:nvSpPr>
+          <p:cNvPr id="20" name="Shape 18">
+            <a:extLst>
+              <a:ext uri="{FF2B5EF4-FFF2-40B4-BE49-F238E27FC236}">
+                <a16:creationId xmlns:a16="http://schemas.microsoft.com/office/drawing/2014/main" id="{902DADD8-0B95-1318-51A0-33AE8B516364}"/>
+              </a:ext>
+            </a:extLst>
+          </p:cNvPr>
+          <p:cNvSpPr/>
+          <p:nvPr/>
+        </p:nvSpPr>
+        <p:spPr>
+          <a:xfrm>
+            <a:off x="548640" y="3459480"/>
+            <a:ext cx="8046720" cy="960120"/>
+          </a:xfrm>
+          <a:prstGeom prst="rect">
+            <a:avLst/>
+          </a:prstGeom>
+          <a:solidFill>
+            <a:srgbClr val="FFFFFF"/>
+          </a:solidFill>
+          <a:ln/>
+          <a:effectLst>
+            <a:outerShdw blurRad="101600" dist="38100" dir="8100000" algn="bl" rotWithShape="0">
+              <a:srgbClr val="000000">
+                <a:alpha val="10000"/>
+              </a:srgbClr>
+            </a:outerShdw>
+          </a:effectLst>
+        </p:spPr>
+      </p:sp>
+      <p:sp>
+        <p:nvSpPr>
+          <p:cNvPr id="21" name="Shape 19">
+            <a:extLst>
+              <a:ext uri="{FF2B5EF4-FFF2-40B4-BE49-F238E27FC236}">
+                <a16:creationId xmlns:a16="http://schemas.microsoft.com/office/drawing/2014/main" id="{EE9760EA-CD46-84BD-47DA-369CB412EFAA}"/>
+              </a:ext>
+            </a:extLst>
+          </p:cNvPr>
+          <p:cNvSpPr/>
+          <p:nvPr/>
+        </p:nvSpPr>
+        <p:spPr>
+          <a:xfrm>
+            <a:off x="548640" y="3459480"/>
+            <a:ext cx="54864" cy="960120"/>
+          </a:xfrm>
+          <a:prstGeom prst="rect">
+            <a:avLst/>
+          </a:prstGeom>
+          <a:solidFill>
+            <a:srgbClr val="8B5CF6"/>
+          </a:solidFill>
+          <a:ln/>
+        </p:spPr>
+      </p:sp>
+      <p:sp>
+        <p:nvSpPr>
+          <p:cNvPr id="22" name="Shape 20">
+            <a:extLst>
+              <a:ext uri="{FF2B5EF4-FFF2-40B4-BE49-F238E27FC236}">
+                <a16:creationId xmlns:a16="http://schemas.microsoft.com/office/drawing/2014/main" id="{B8CFF72A-674E-182A-3AFB-9A96B9743E9F}"/>
+              </a:ext>
+            </a:extLst>
+          </p:cNvPr>
+          <p:cNvSpPr/>
+          <p:nvPr/>
+        </p:nvSpPr>
+        <p:spPr>
+          <a:xfrm>
+            <a:off x="777240" y="3688080"/>
+            <a:ext cx="411480" cy="411480"/>
+          </a:xfrm>
+          <a:prstGeom prst="ellipse">
+            <a:avLst/>
+          </a:prstGeom>
+          <a:solidFill>
+            <a:srgbClr val="8B5CF6"/>
+          </a:solidFill>
+          <a:ln/>
+        </p:spPr>
+      </p:sp>
+      <p:sp>
+        <p:nvSpPr>
+          <p:cNvPr id="23" name="Text 21">
+            <a:extLst>
+              <a:ext uri="{FF2B5EF4-FFF2-40B4-BE49-F238E27FC236}">
+                <a16:creationId xmlns:a16="http://schemas.microsoft.com/office/drawing/2014/main" id="{B86C407A-1D20-BF9F-04B8-98B7667CDA68}"/>
+              </a:ext>
+            </a:extLst>
+          </p:cNvPr>
+          <p:cNvSpPr/>
+          <p:nvPr/>
+        </p:nvSpPr>
+        <p:spPr>
+          <a:xfrm>
+            <a:off x="777240" y="3688080"/>
+            <a:ext cx="411480" cy="411480"/>
+          </a:xfrm>
+          <a:prstGeom prst="rect">
+            <a:avLst/>
+          </a:prstGeom>
+          <a:noFill/>
+          <a:ln/>
+        </p:spPr>
+        <p:txBody>
+          <a:bodyPr wrap="square" lIns="0" tIns="0" rIns="0" bIns="0" rtlCol="0" anchor="ctr"/>
+          <a:lstStyle/>
+          <a:p>
+            <a:pPr marL="0" indent="0" algn="ctr">
+              <a:buNone/>
+            </a:pPr>
+            <a:r>
+              <a:rPr lang="en-US" sz="1600" b="1" dirty="0">
+                <a:solidFill>
+                  <a:srgbClr val="FFFFFF"/>
+                </a:solidFill>
+                <a:ea typeface="Trebuchet MS" pitchFamily="34" charset="-122"/>
+                <a:cs typeface="Trebuchet MS" pitchFamily="34" charset="-120"/>
+              </a:rPr>
+              <a:t>3</a:t>
+            </a:r>
+            <a:endParaRPr lang="en-US" sz="1600" dirty="0"/>
+          </a:p>
+        </p:txBody>
+      </p:sp>
+      <p:sp>
+        <p:nvSpPr>
+          <p:cNvPr id="24" name="Text 22">
+            <a:extLst>
+              <a:ext uri="{FF2B5EF4-FFF2-40B4-BE49-F238E27FC236}">
+                <a16:creationId xmlns:a16="http://schemas.microsoft.com/office/drawing/2014/main" id="{76815E32-86FE-6470-A71B-A57FE7CBDAA3}"/>
+              </a:ext>
+            </a:extLst>
+          </p:cNvPr>
+          <p:cNvSpPr/>
+          <p:nvPr/>
+        </p:nvSpPr>
+        <p:spPr>
+          <a:xfrm>
+            <a:off x="1371600" y="3569208"/>
+            <a:ext cx="4091940" cy="320040"/>
+          </a:xfrm>
+          <a:prstGeom prst="rect">
+            <a:avLst/>
+          </a:prstGeom>
+          <a:noFill/>
+          <a:ln/>
+        </p:spPr>
+        <p:txBody>
+          <a:bodyPr wrap="square" lIns="0" tIns="0" rIns="0" bIns="0" rtlCol="0" anchor="ctr"/>
+          <a:lstStyle/>
+          <a:p>
+            <a:pPr marL="0" indent="0">
+              <a:buNone/>
+            </a:pPr>
+            <a:r>
+              <a:rPr lang="en-US" sz="1500" b="1" dirty="0">
+                <a:solidFill>
+                  <a:srgbClr val="0F172A"/>
+                </a:solidFill>
+                <a:ea typeface="Trebuchet MS" pitchFamily="34" charset="-122"/>
+                <a:cs typeface="Trebuchet MS" pitchFamily="34" charset="-120"/>
+              </a:rPr>
+              <a:t>Production pipelines (cloud / on-premise)</a:t>
+            </a:r>
+            <a:endParaRPr lang="en-US" sz="1500" dirty="0"/>
+          </a:p>
+        </p:txBody>
+      </p:sp>
+      <p:sp>
+        <p:nvSpPr>
+          <p:cNvPr id="25" name="Text 23">
+            <a:extLst>
+              <a:ext uri="{FF2B5EF4-FFF2-40B4-BE49-F238E27FC236}">
+                <a16:creationId xmlns:a16="http://schemas.microsoft.com/office/drawing/2014/main" id="{08032C9C-5FE4-807C-4DB7-7B5BE5CC0826}"/>
+              </a:ext>
+            </a:extLst>
+          </p:cNvPr>
+          <p:cNvSpPr/>
+          <p:nvPr/>
+        </p:nvSpPr>
+        <p:spPr>
+          <a:xfrm>
+            <a:off x="1371600" y="3898392"/>
+            <a:ext cx="6949440" cy="457200"/>
+          </a:xfrm>
+          <a:prstGeom prst="rect">
+            <a:avLst/>
+          </a:prstGeom>
+          <a:noFill/>
+          <a:ln/>
+        </p:spPr>
+        <p:txBody>
+          <a:bodyPr wrap="square" lIns="0" tIns="0" rIns="0" bIns="0" rtlCol="0" anchor="ctr"/>
+          <a:lstStyle/>
+          <a:p>
+            <a:pPr marL="0" indent="0">
+              <a:buNone/>
+            </a:pPr>
+            <a:r>
+              <a:rPr lang="en-US" sz="1200" dirty="0">
+                <a:solidFill>
+                  <a:srgbClr val="475569"/>
+                </a:solidFill>
+                <a:ea typeface="Calibri" pitchFamily="34" charset="-122"/>
+                <a:cs typeface="Calibri" pitchFamily="34" charset="-120"/>
+              </a:rPr>
+              <a:t>MLflow hosts and deploys models. Separating training and deployment pipelines improves maintenance, security, and reliability.</a:t>
+            </a:r>
+            <a:endParaRPr lang="en-US" sz="1200" dirty="0"/>
+          </a:p>
+        </p:txBody>
+      </p:sp>
+    </p:spTree>
+    <p:extLst>
+      <p:ext uri="{BB962C8B-B14F-4D97-AF65-F5344CB8AC3E}">
+        <p14:creationId xmlns:p14="http://schemas.microsoft.com/office/powerpoint/2010/main" val="2297595068"/>
       </p:ext>
     </p:extLst>
   </p:cSld>
@@ -14925,7 +15519,7 @@
           <a:p>
             <a:r>
               <a:rPr lang="fr-FR" dirty="0" err="1"/>
-              <a:t>Other</a:t>
+              <a:t>Today’s</a:t>
             </a:r>
             <a:r>
               <a:rPr lang="fr-FR" dirty="0"/>
@@ -14933,7 +15527,15 @@
             </a:r>
             <a:r>
               <a:rPr lang="fr-FR" dirty="0" err="1"/>
-              <a:t>examples</a:t>
+              <a:t>Lab</a:t>
+            </a:r>
+            <a:r>
+              <a:rPr lang="fr-FR" dirty="0"/>
+              <a:t> &amp; </a:t>
+            </a:r>
+            <a:r>
+              <a:rPr lang="fr-FR" dirty="0" err="1"/>
+              <a:t>Resources</a:t>
             </a:r>
             <a:endParaRPr lang="fr-FR" dirty="0"/>
           </a:p>
@@ -14968,241 +15570,9 @@
           </a:p>
         </p:txBody>
       </p:sp>
-      <p:pic>
-        <p:nvPicPr>
-          <p:cNvPr id="7" name="Image 6"/>
-          <p:cNvPicPr>
-            <a:picLocks noChangeAspect="1"/>
-          </p:cNvPicPr>
-          <p:nvPr/>
-        </p:nvPicPr>
-        <p:blipFill>
-          <a:blip r:embed="rId2"/>
-          <a:stretch>
-            <a:fillRect/>
-          </a:stretch>
-        </p:blipFill>
-        <p:spPr>
-          <a:xfrm>
-            <a:off x="2071255" y="1021649"/>
-            <a:ext cx="4405742" cy="3584988"/>
-          </a:xfrm>
-          <a:prstGeom prst="rect">
-            <a:avLst/>
-          </a:prstGeom>
-        </p:spPr>
-      </p:pic>
-      <p:sp>
-        <p:nvSpPr>
-          <p:cNvPr id="8" name="Espace réservé du texte 2"/>
-          <p:cNvSpPr txBox="1">
-            <a:spLocks/>
-          </p:cNvSpPr>
-          <p:nvPr/>
-        </p:nvSpPr>
-        <p:spPr bwMode="auto">
-          <a:xfrm>
-            <a:off x="7531252" y="4353583"/>
-            <a:ext cx="1552298" cy="297260"/>
-          </a:xfrm>
-          <a:prstGeom prst="rect">
-            <a:avLst/>
-          </a:prstGeom>
-          <a:noFill/>
-          <a:ln w="9525">
-            <a:noFill/>
-            <a:miter lim="800000"/>
-            <a:headEnd/>
-            <a:tailEnd/>
-          </a:ln>
-        </p:spPr>
-        <p:txBody>
-          <a:bodyPr vert="horz" wrap="square" lIns="68580" tIns="34290" rIns="68580" bIns="34290" numCol="1" anchor="t" anchorCtr="0" compatLnSpc="1">
-            <a:prstTxWarp prst="textNoShape">
-              <a:avLst/>
-            </a:prstTxWarp>
-          </a:bodyPr>
-          <a:lstStyle>
-            <a:lvl1pPr marL="285750" indent="-285750" algn="l" rtl="0" eaLnBrk="1" fontAlgn="base" hangingPunct="1">
-              <a:lnSpc>
-                <a:spcPct val="110000"/>
-              </a:lnSpc>
-              <a:spcBef>
-                <a:spcPts val="0"/>
-              </a:spcBef>
-              <a:spcAft>
-                <a:spcPts val="600"/>
-              </a:spcAft>
-              <a:buFont typeface="Arial" panose="020B0604020202020204" pitchFamily="34" charset="0"/>
-              <a:buChar char="•"/>
-              <a:defRPr lang="fr-FR" sz="1800" b="0" i="0" kern="1200">
-                <a:solidFill>
-                  <a:schemeClr val="tx1"/>
-                </a:solidFill>
-                <a:latin typeface="Segoe UI" panose="020B0502040204020203" pitchFamily="34" charset="0"/>
-                <a:ea typeface="+mn-ea"/>
-                <a:cs typeface="Segoe UI" panose="020B0502040204020203" pitchFamily="34" charset="0"/>
-              </a:defRPr>
-            </a:lvl1pPr>
-            <a:lvl2pPr marL="612775" indent="-342900" algn="l" rtl="0" eaLnBrk="1" fontAlgn="base" hangingPunct="1">
-              <a:lnSpc>
-                <a:spcPct val="110000"/>
-              </a:lnSpc>
-              <a:spcBef>
-                <a:spcPts val="0"/>
-              </a:spcBef>
-              <a:spcAft>
-                <a:spcPts val="600"/>
-              </a:spcAft>
-              <a:buFont typeface="Browallia New" panose="020B0604020202020204" pitchFamily="34" charset="-34"/>
-              <a:buChar char="›"/>
-              <a:defRPr lang="fr-FR" sz="1600" b="0" i="0" kern="1200">
-                <a:solidFill>
-                  <a:schemeClr val="tx1"/>
-                </a:solidFill>
-                <a:latin typeface="Segoe UI" panose="020B0502040204020203" pitchFamily="34" charset="0"/>
-                <a:ea typeface="+mn-ea"/>
-                <a:cs typeface="Segoe UI" panose="020B0502040204020203" pitchFamily="34" charset="0"/>
-              </a:defRPr>
-            </a:lvl2pPr>
-            <a:lvl3pPr marL="920750" indent="-342900" algn="l" rtl="0" eaLnBrk="1" fontAlgn="base" hangingPunct="1">
-              <a:lnSpc>
-                <a:spcPct val="110000"/>
-              </a:lnSpc>
-              <a:spcBef>
-                <a:spcPts val="0"/>
-              </a:spcBef>
-              <a:spcAft>
-                <a:spcPts val="600"/>
-              </a:spcAft>
-              <a:buFont typeface="Calibri" panose="020F0502020204030204" pitchFamily="34" charset="0"/>
-              <a:buChar char="»"/>
-              <a:defRPr lang="fr-FR" sz="1400" b="0" i="0" kern="1200">
-                <a:solidFill>
-                  <a:schemeClr val="tx1"/>
-                </a:solidFill>
-                <a:latin typeface="Segoe UI" panose="020B0502040204020203" pitchFamily="34" charset="0"/>
-                <a:ea typeface="+mn-ea"/>
-                <a:cs typeface="Segoe UI" panose="020B0502040204020203" pitchFamily="34" charset="0"/>
-              </a:defRPr>
-            </a:lvl3pPr>
-            <a:lvl4pPr marL="1165225" indent="-285750" algn="l" rtl="0" eaLnBrk="1" fontAlgn="base" hangingPunct="1">
-              <a:lnSpc>
-                <a:spcPct val="110000"/>
-              </a:lnSpc>
-              <a:spcBef>
-                <a:spcPts val="0"/>
-              </a:spcBef>
-              <a:spcAft>
-                <a:spcPts val="600"/>
-              </a:spcAft>
-              <a:buFont typeface="Segoe UI" panose="020B0502040204020203" pitchFamily="34" charset="0"/>
-              <a:buChar char="‑"/>
-              <a:defRPr lang="fr-FR" sz="1400" b="0" i="0" kern="1200">
-                <a:solidFill>
-                  <a:schemeClr val="tx1"/>
-                </a:solidFill>
-                <a:latin typeface="Segoe UI" panose="020B0502040204020203" pitchFamily="34" charset="0"/>
-                <a:ea typeface="+mn-ea"/>
-                <a:cs typeface="Segoe UI" panose="020B0502040204020203" pitchFamily="34" charset="0"/>
-              </a:defRPr>
-            </a:lvl4pPr>
-            <a:lvl5pPr marL="1828800" indent="0" algn="l" rtl="0" eaLnBrk="1" fontAlgn="base" hangingPunct="1">
-              <a:spcBef>
-                <a:spcPct val="20000"/>
-              </a:spcBef>
-              <a:spcAft>
-                <a:spcPct val="0"/>
-              </a:spcAft>
-              <a:buFont typeface="Arial" panose="020B0604020202020204" pitchFamily="34" charset="0"/>
-              <a:buNone/>
-              <a:defRPr sz="2000" kern="1200">
-                <a:solidFill>
-                  <a:schemeClr val="tx1">
-                    <a:lumMod val="75000"/>
-                    <a:lumOff val="25000"/>
-                  </a:schemeClr>
-                </a:solidFill>
-                <a:latin typeface="Browallia New" panose="020B0604020202020204" pitchFamily="34" charset="-34"/>
-                <a:ea typeface="+mn-ea"/>
-                <a:cs typeface="Browallia New" panose="020B0604020202020204" pitchFamily="34" charset="-34"/>
-              </a:defRPr>
-            </a:lvl5pPr>
-            <a:lvl6pPr marL="2514600" indent="-228600" algn="l" defTabSz="914400" rtl="0" eaLnBrk="1" latinLnBrk="0" hangingPunct="1">
-              <a:spcBef>
-                <a:spcPct val="20000"/>
-              </a:spcBef>
-              <a:buFont typeface="Arial" pitchFamily="34" charset="0"/>
-              <a:buChar char="•"/>
-              <a:defRPr sz="2000" kern="1200">
-                <a:solidFill>
-                  <a:schemeClr val="tx1"/>
-                </a:solidFill>
-                <a:latin typeface="+mn-lt"/>
-                <a:ea typeface="+mn-ea"/>
-                <a:cs typeface="+mn-cs"/>
-              </a:defRPr>
-            </a:lvl6pPr>
-            <a:lvl7pPr marL="2971800" indent="-228600" algn="l" defTabSz="914400" rtl="0" eaLnBrk="1" latinLnBrk="0" hangingPunct="1">
-              <a:spcBef>
-                <a:spcPct val="20000"/>
-              </a:spcBef>
-              <a:buFont typeface="Arial" pitchFamily="34" charset="0"/>
-              <a:buChar char="•"/>
-              <a:defRPr sz="2000" kern="1200">
-                <a:solidFill>
-                  <a:schemeClr val="tx1"/>
-                </a:solidFill>
-                <a:latin typeface="+mn-lt"/>
-                <a:ea typeface="+mn-ea"/>
-                <a:cs typeface="+mn-cs"/>
-              </a:defRPr>
-            </a:lvl7pPr>
-            <a:lvl8pPr marL="3429000" indent="-228600" algn="l" defTabSz="914400" rtl="0" eaLnBrk="1" latinLnBrk="0" hangingPunct="1">
-              <a:spcBef>
-                <a:spcPct val="20000"/>
-              </a:spcBef>
-              <a:buFont typeface="Arial" pitchFamily="34" charset="0"/>
-              <a:buChar char="•"/>
-              <a:defRPr sz="2000" kern="1200">
-                <a:solidFill>
-                  <a:schemeClr val="tx1"/>
-                </a:solidFill>
-                <a:latin typeface="+mn-lt"/>
-                <a:ea typeface="+mn-ea"/>
-                <a:cs typeface="+mn-cs"/>
-              </a:defRPr>
-            </a:lvl8pPr>
-            <a:lvl9pPr marL="3886200" indent="-228600" algn="l" defTabSz="914400" rtl="0" eaLnBrk="1" latinLnBrk="0" hangingPunct="1">
-              <a:spcBef>
-                <a:spcPct val="20000"/>
-              </a:spcBef>
-              <a:buFont typeface="Arial" pitchFamily="34" charset="0"/>
-              <a:buChar char="•"/>
-              <a:defRPr sz="2000" kern="1200">
-                <a:solidFill>
-                  <a:schemeClr val="tx1"/>
-                </a:solidFill>
-                <a:latin typeface="+mn-lt"/>
-                <a:ea typeface="+mn-ea"/>
-                <a:cs typeface="+mn-cs"/>
-              </a:defRPr>
-            </a:lvl9pPr>
-          </a:lstStyle>
-          <a:p>
-            <a:pPr marL="0" indent="0">
-              <a:buNone/>
-            </a:pPr>
-            <a:r>
-              <a:rPr lang="fr-FR" sz="900" i="1" dirty="0"/>
-              <a:t>Source : mlflow.org</a:t>
-            </a:r>
-          </a:p>
-        </p:txBody>
-      </p:sp>
-      <p:sp>
-        <p:nvSpPr>
-          <p:cNvPr id="9" name="Espace réservé du pied de page 4"/>
+      <p:sp>
+        <p:nvSpPr>
+          <p:cNvPr id="6" name="Espace réservé du pied de page 4"/>
           <p:cNvSpPr>
             <a:spLocks noGrp="1"/>
           </p:cNvSpPr>
@@ -15228,10 +15598,561 @@
           </a:p>
         </p:txBody>
       </p:sp>
+      <p:sp>
+        <p:nvSpPr>
+          <p:cNvPr id="25" name="Shape 6">
+            <a:extLst>
+              <a:ext uri="{FF2B5EF4-FFF2-40B4-BE49-F238E27FC236}">
+                <a16:creationId xmlns:a16="http://schemas.microsoft.com/office/drawing/2014/main" id="{62627B01-911E-8CEC-547D-2DC483113344}"/>
+              </a:ext>
+            </a:extLst>
+          </p:cNvPr>
+          <p:cNvSpPr/>
+          <p:nvPr/>
+        </p:nvSpPr>
+        <p:spPr>
+          <a:xfrm>
+            <a:off x="548640" y="1234440"/>
+            <a:ext cx="5029200" cy="2412492"/>
+          </a:xfrm>
+          <a:prstGeom prst="rect">
+            <a:avLst/>
+          </a:prstGeom>
+          <a:solidFill>
+            <a:srgbClr val="FFFFFF"/>
+          </a:solidFill>
+          <a:ln/>
+          <a:effectLst>
+            <a:outerShdw blurRad="101600" dist="38100" dir="8100000" algn="bl" rotWithShape="0">
+              <a:srgbClr val="000000">
+                <a:alpha val="10000"/>
+              </a:srgbClr>
+            </a:outerShdw>
+          </a:effectLst>
+        </p:spPr>
+      </p:sp>
+      <p:sp>
+        <p:nvSpPr>
+          <p:cNvPr id="26" name="Shape 7">
+            <a:extLst>
+              <a:ext uri="{FF2B5EF4-FFF2-40B4-BE49-F238E27FC236}">
+                <a16:creationId xmlns:a16="http://schemas.microsoft.com/office/drawing/2014/main" id="{D0B6BC73-6E59-3C4C-A54C-E29BAD27F1A5}"/>
+              </a:ext>
+            </a:extLst>
+          </p:cNvPr>
+          <p:cNvSpPr/>
+          <p:nvPr/>
+        </p:nvSpPr>
+        <p:spPr>
+          <a:xfrm>
+            <a:off x="548640" y="1234440"/>
+            <a:ext cx="54864" cy="2412492"/>
+          </a:xfrm>
+          <a:prstGeom prst="rect">
+            <a:avLst/>
+          </a:prstGeom>
+          <a:solidFill>
+            <a:srgbClr val="0EA5E9"/>
+          </a:solidFill>
+          <a:ln/>
+        </p:spPr>
+      </p:sp>
+      <p:sp>
+        <p:nvSpPr>
+          <p:cNvPr id="27" name="Text 8">
+            <a:extLst>
+              <a:ext uri="{FF2B5EF4-FFF2-40B4-BE49-F238E27FC236}">
+                <a16:creationId xmlns:a16="http://schemas.microsoft.com/office/drawing/2014/main" id="{A76D05D1-5449-30A9-BBB6-251918712253}"/>
+              </a:ext>
+            </a:extLst>
+          </p:cNvPr>
+          <p:cNvSpPr/>
+          <p:nvPr/>
+        </p:nvSpPr>
+        <p:spPr>
+          <a:xfrm>
+            <a:off x="777240" y="1325880"/>
+            <a:ext cx="4572000" cy="365760"/>
+          </a:xfrm>
+          <a:prstGeom prst="rect">
+            <a:avLst/>
+          </a:prstGeom>
+          <a:noFill/>
+          <a:ln/>
+        </p:spPr>
+        <p:txBody>
+          <a:bodyPr wrap="square" lIns="0" tIns="0" rIns="0" bIns="0" rtlCol="0" anchor="ctr"/>
+          <a:lstStyle/>
+          <a:p>
+            <a:pPr marL="0" indent="0">
+              <a:buNone/>
+            </a:pPr>
+            <a:r>
+              <a:rPr lang="en-US" sz="1600" b="1" dirty="0">
+                <a:solidFill>
+                  <a:srgbClr val="0EA5E9"/>
+                </a:solidFill>
+                <a:ea typeface="Trebuchet MS" pitchFamily="34" charset="-122"/>
+                <a:cs typeface="Trebuchet MS" pitchFamily="34" charset="-120"/>
+              </a:rPr>
+              <a:t>Lab 01 — MLflow Experiment Tracking</a:t>
+            </a:r>
+            <a:endParaRPr lang="en-US" sz="1600" dirty="0"/>
+          </a:p>
+        </p:txBody>
+      </p:sp>
+      <p:sp>
+        <p:nvSpPr>
+          <p:cNvPr id="28" name="Text 9">
+            <a:extLst>
+              <a:ext uri="{FF2B5EF4-FFF2-40B4-BE49-F238E27FC236}">
+                <a16:creationId xmlns:a16="http://schemas.microsoft.com/office/drawing/2014/main" id="{19FCB265-E1E7-09AA-5211-7D2B70AD0A2D}"/>
+              </a:ext>
+            </a:extLst>
+          </p:cNvPr>
+          <p:cNvSpPr/>
+          <p:nvPr/>
+        </p:nvSpPr>
+        <p:spPr>
+          <a:xfrm>
+            <a:off x="777240" y="1691640"/>
+            <a:ext cx="4572000" cy="274320"/>
+          </a:xfrm>
+          <a:prstGeom prst="rect">
+            <a:avLst/>
+          </a:prstGeom>
+          <a:noFill/>
+          <a:ln/>
+        </p:spPr>
+        <p:txBody>
+          <a:bodyPr wrap="square" lIns="0" tIns="0" rIns="0" bIns="0" rtlCol="0" anchor="ctr"/>
+          <a:lstStyle/>
+          <a:p>
+            <a:pPr marL="0" indent="0">
+              <a:buNone/>
+            </a:pPr>
+            <a:r>
+              <a:rPr lang="en-US" sz="1100" dirty="0">
+                <a:solidFill>
+                  <a:srgbClr val="94A3B8"/>
+                </a:solidFill>
+                <a:ea typeface="Calibri" pitchFamily="34" charset="-122"/>
+                <a:cs typeface="Calibri" pitchFamily="34" charset="-120"/>
+              </a:rPr>
+              <a:t>~2h30  |  German Credit Risk dataset</a:t>
+            </a:r>
+            <a:endParaRPr lang="en-US" sz="1100" dirty="0"/>
+          </a:p>
+        </p:txBody>
+      </p:sp>
+      <p:sp>
+        <p:nvSpPr>
+          <p:cNvPr id="29" name="Shape 11">
+            <a:extLst>
+              <a:ext uri="{FF2B5EF4-FFF2-40B4-BE49-F238E27FC236}">
+                <a16:creationId xmlns:a16="http://schemas.microsoft.com/office/drawing/2014/main" id="{AD138B40-F698-08D2-C04B-32D3DBC28231}"/>
+              </a:ext>
+            </a:extLst>
+          </p:cNvPr>
+          <p:cNvSpPr/>
+          <p:nvPr/>
+        </p:nvSpPr>
+        <p:spPr>
+          <a:xfrm>
+            <a:off x="5943600" y="1234440"/>
+            <a:ext cx="2743200" cy="2412492"/>
+          </a:xfrm>
+          <a:prstGeom prst="rect">
+            <a:avLst/>
+          </a:prstGeom>
+          <a:solidFill>
+            <a:srgbClr val="FFFFFF"/>
+          </a:solidFill>
+          <a:ln/>
+          <a:effectLst>
+            <a:outerShdw blurRad="101600" dist="38100" dir="8100000" algn="bl" rotWithShape="0">
+              <a:srgbClr val="000000">
+                <a:alpha val="10000"/>
+              </a:srgbClr>
+            </a:outerShdw>
+          </a:effectLst>
+        </p:spPr>
+      </p:sp>
+      <p:sp>
+        <p:nvSpPr>
+          <p:cNvPr id="30" name="Shape 12">
+            <a:extLst>
+              <a:ext uri="{FF2B5EF4-FFF2-40B4-BE49-F238E27FC236}">
+                <a16:creationId xmlns:a16="http://schemas.microsoft.com/office/drawing/2014/main" id="{628CA839-1282-F302-5D78-4C9AE63FB55E}"/>
+              </a:ext>
+            </a:extLst>
+          </p:cNvPr>
+          <p:cNvSpPr/>
+          <p:nvPr/>
+        </p:nvSpPr>
+        <p:spPr>
+          <a:xfrm>
+            <a:off x="5943600" y="1234440"/>
+            <a:ext cx="54864" cy="2412492"/>
+          </a:xfrm>
+          <a:prstGeom prst="rect">
+            <a:avLst/>
+          </a:prstGeom>
+          <a:solidFill>
+            <a:srgbClr val="F59E0B"/>
+          </a:solidFill>
+          <a:ln/>
+        </p:spPr>
+      </p:sp>
+      <p:sp>
+        <p:nvSpPr>
+          <p:cNvPr id="31" name="Text 13">
+            <a:extLst>
+              <a:ext uri="{FF2B5EF4-FFF2-40B4-BE49-F238E27FC236}">
+                <a16:creationId xmlns:a16="http://schemas.microsoft.com/office/drawing/2014/main" id="{EDEB5970-149C-583F-F2FA-D94857ABE3D2}"/>
+              </a:ext>
+            </a:extLst>
+          </p:cNvPr>
+          <p:cNvSpPr/>
+          <p:nvPr/>
+        </p:nvSpPr>
+        <p:spPr>
+          <a:xfrm>
+            <a:off x="6126480" y="1325880"/>
+            <a:ext cx="2377440" cy="365760"/>
+          </a:xfrm>
+          <a:prstGeom prst="rect">
+            <a:avLst/>
+          </a:prstGeom>
+          <a:noFill/>
+          <a:ln/>
+        </p:spPr>
+        <p:txBody>
+          <a:bodyPr wrap="square" lIns="0" tIns="0" rIns="0" bIns="0" rtlCol="0" anchor="ctr"/>
+          <a:lstStyle/>
+          <a:p>
+            <a:pPr marL="0" indent="0">
+              <a:buNone/>
+            </a:pPr>
+            <a:r>
+              <a:rPr lang="en-US" sz="1400" b="1" dirty="0">
+                <a:solidFill>
+                  <a:srgbClr val="F59E0B"/>
+                </a:solidFill>
+                <a:ea typeface="Trebuchet MS" pitchFamily="34" charset="-122"/>
+                <a:cs typeface="Trebuchet MS" pitchFamily="34" charset="-120"/>
+              </a:rPr>
+              <a:t>Resources</a:t>
+            </a:r>
+            <a:endParaRPr lang="en-US" sz="1400" dirty="0"/>
+          </a:p>
+        </p:txBody>
+      </p:sp>
+      <p:sp>
+        <p:nvSpPr>
+          <p:cNvPr id="32" name="Text 10">
+            <a:extLst>
+              <a:ext uri="{FF2B5EF4-FFF2-40B4-BE49-F238E27FC236}">
+                <a16:creationId xmlns:a16="http://schemas.microsoft.com/office/drawing/2014/main" id="{54096B3F-653A-74D1-DF63-A674F6F87645}"/>
+              </a:ext>
+            </a:extLst>
+          </p:cNvPr>
+          <p:cNvSpPr/>
+          <p:nvPr/>
+        </p:nvSpPr>
+        <p:spPr>
+          <a:xfrm>
+            <a:off x="777240" y="2011680"/>
+            <a:ext cx="4572000" cy="1409700"/>
+          </a:xfrm>
+          <a:prstGeom prst="rect">
+            <a:avLst/>
+          </a:prstGeom>
+          <a:noFill/>
+          <a:ln/>
+        </p:spPr>
+        <p:txBody>
+          <a:bodyPr wrap="square" lIns="0" tIns="0" rIns="0" bIns="0" rtlCol="0" anchor="t"/>
+          <a:lstStyle/>
+          <a:p>
+            <a:pPr marL="0" indent="0">
+              <a:buNone/>
+            </a:pPr>
+            <a:r>
+              <a:rPr lang="en-US" sz="1200" b="1" dirty="0">
+                <a:solidFill>
+                  <a:srgbClr val="0F172A"/>
+                </a:solidFill>
+              </a:rPr>
+              <a:t>What you will learn:</a:t>
+            </a:r>
+            <a:endParaRPr lang="en-US" sz="1200" dirty="0"/>
+          </a:p>
+          <a:p>
+            <a:pPr marL="0" indent="0">
+              <a:buNone/>
+            </a:pPr>
+            <a:r>
+              <a:rPr lang="en-US" sz="400" dirty="0">
+                <a:solidFill>
+                  <a:srgbClr val="000000"/>
+                </a:solidFill>
+              </a:rPr>
+              <a:t>
+</a:t>
+            </a:r>
+            <a:endParaRPr lang="en-US" sz="1200" dirty="0"/>
+          </a:p>
+          <a:p>
+            <a:pPr marL="342900" indent="-342900">
+              <a:buSzPct val="100000"/>
+              <a:buChar char="•"/>
+            </a:pPr>
+            <a:r>
+              <a:rPr lang="en-US" sz="1100" dirty="0">
+                <a:solidFill>
+                  <a:srgbClr val="475569"/>
+                </a:solidFill>
+              </a:rPr>
+              <a:t>Launch &amp; connect to an MLflow tracking server</a:t>
+            </a:r>
+            <a:endParaRPr lang="en-US" sz="1200" dirty="0"/>
+          </a:p>
+          <a:p>
+            <a:pPr marL="342900" indent="-342900">
+              <a:buSzPct val="100000"/>
+              <a:buChar char="•"/>
+            </a:pPr>
+            <a:r>
+              <a:rPr lang="en-US" sz="1100" dirty="0">
+                <a:solidFill>
+                  <a:srgbClr val="475569"/>
+                </a:solidFill>
+              </a:rPr>
+              <a:t>Log parameters, metrics, and artifacts</a:t>
+            </a:r>
+            <a:endParaRPr lang="en-US" sz="1200" dirty="0"/>
+          </a:p>
+          <a:p>
+            <a:pPr marL="342900" indent="-342900">
+              <a:buSzPct val="100000"/>
+              <a:buChar char="•"/>
+            </a:pPr>
+            <a:r>
+              <a:rPr lang="en-US" sz="1100" dirty="0">
+                <a:solidFill>
+                  <a:srgbClr val="475569"/>
+                </a:solidFill>
+              </a:rPr>
+              <a:t>Compare runs using the MLflow UI</a:t>
+            </a:r>
+            <a:endParaRPr lang="en-US" sz="1200" dirty="0"/>
+          </a:p>
+          <a:p>
+            <a:pPr marL="342900" indent="-342900">
+              <a:buSzPct val="100000"/>
+              <a:buChar char="•"/>
+            </a:pPr>
+            <a:r>
+              <a:rPr lang="en-US" sz="1100" dirty="0">
+                <a:solidFill>
+                  <a:srgbClr val="475569"/>
+                </a:solidFill>
+              </a:rPr>
+              <a:t>Automate hyperparameter search with Optuna</a:t>
+            </a:r>
+            <a:endParaRPr lang="en-US" sz="1200" dirty="0"/>
+          </a:p>
+          <a:p>
+            <a:pPr marL="342900" indent="-342900">
+              <a:buSzPct val="100000"/>
+              <a:buChar char="•"/>
+            </a:pPr>
+            <a:r>
+              <a:rPr lang="en-US" sz="1100" dirty="0">
+                <a:solidFill>
+                  <a:srgbClr val="475569"/>
+                </a:solidFill>
+              </a:rPr>
+              <a:t>Register and version models in the Model Registry</a:t>
+            </a:r>
+            <a:endParaRPr lang="en-US" sz="1200" dirty="0"/>
+          </a:p>
+          <a:p>
+            <a:pPr marL="342900" indent="-342900">
+              <a:buSzPct val="100000"/>
+              <a:buChar char="•"/>
+            </a:pPr>
+            <a:r>
+              <a:rPr lang="en-US" sz="1100" dirty="0">
+                <a:solidFill>
+                  <a:srgbClr val="475569"/>
+                </a:solidFill>
+              </a:rPr>
+              <a:t>Load a registered model for inference</a:t>
+            </a:r>
+            <a:endParaRPr lang="en-US" sz="1200" dirty="0"/>
+          </a:p>
+        </p:txBody>
+      </p:sp>
+      <p:sp>
+        <p:nvSpPr>
+          <p:cNvPr id="33" name="Text 14">
+            <a:extLst>
+              <a:ext uri="{FF2B5EF4-FFF2-40B4-BE49-F238E27FC236}">
+                <a16:creationId xmlns:a16="http://schemas.microsoft.com/office/drawing/2014/main" id="{F8298D38-ED21-089D-3F9D-DB54A38DF7DC}"/>
+              </a:ext>
+            </a:extLst>
+          </p:cNvPr>
+          <p:cNvSpPr/>
+          <p:nvPr/>
+        </p:nvSpPr>
+        <p:spPr>
+          <a:xfrm>
+            <a:off x="6126480" y="1836420"/>
+            <a:ext cx="2377440" cy="1684020"/>
+          </a:xfrm>
+          <a:prstGeom prst="rect">
+            <a:avLst/>
+          </a:prstGeom>
+          <a:noFill/>
+          <a:ln/>
+        </p:spPr>
+        <p:txBody>
+          <a:bodyPr wrap="square" lIns="0" tIns="0" rIns="0" bIns="0" rtlCol="0" anchor="t"/>
+          <a:lstStyle/>
+          <a:p>
+            <a:pPr marL="0" indent="0">
+              <a:buNone/>
+            </a:pPr>
+            <a:r>
+              <a:rPr lang="en-US" sz="1000" b="1" dirty="0">
+                <a:solidFill>
+                  <a:srgbClr val="0F172A"/>
+                </a:solidFill>
+              </a:rPr>
+              <a:t>Papers:</a:t>
+            </a:r>
+            <a:endParaRPr lang="en-US" sz="1000" dirty="0"/>
+          </a:p>
+          <a:p>
+            <a:pPr marL="0" indent="0">
+              <a:buNone/>
+            </a:pPr>
+            <a:r>
+              <a:rPr lang="en-US" sz="400" dirty="0">
+                <a:solidFill>
+                  <a:srgbClr val="000000"/>
+                </a:solidFill>
+              </a:rPr>
+              <a:t>
+</a:t>
+            </a:r>
+            <a:endParaRPr lang="en-US" sz="1000" dirty="0"/>
+          </a:p>
+          <a:p>
+            <a:pPr marL="0" indent="0">
+              <a:buNone/>
+            </a:pPr>
+            <a:r>
+              <a:rPr lang="en-US" sz="900" dirty="0">
+                <a:solidFill>
+                  <a:srgbClr val="475569"/>
+                </a:solidFill>
+                <a:hlinkClick r:id="rId2"/>
+              </a:rPr>
+              <a:t>Hidden Technical Debt in ML Systems (Google, 2015)</a:t>
+            </a:r>
+            <a:endParaRPr lang="en-US" sz="1000" dirty="0"/>
+          </a:p>
+          <a:p>
+            <a:pPr marL="0" indent="0">
+              <a:buNone/>
+            </a:pPr>
+            <a:r>
+              <a:rPr lang="en-US" sz="400" dirty="0">
+                <a:solidFill>
+                  <a:srgbClr val="000000"/>
+                </a:solidFill>
+              </a:rPr>
+              <a:t>
+</a:t>
+            </a:r>
+            <a:endParaRPr lang="en-US" sz="1000" dirty="0">
+              <a:hlinkClick r:id="rId3"/>
+            </a:endParaRPr>
+          </a:p>
+          <a:p>
+            <a:pPr marL="0" indent="0">
+              <a:buNone/>
+            </a:pPr>
+            <a:r>
+              <a:rPr lang="en-US" sz="900" dirty="0">
+                <a:solidFill>
+                  <a:srgbClr val="475569"/>
+                </a:solidFill>
+                <a:hlinkClick r:id="rId3"/>
+              </a:rPr>
+              <a:t>Build &amp; Deploy GenAI/ML in the Enterprise (Google, 2024)</a:t>
+            </a:r>
+            <a:endParaRPr lang="en-US" sz="1000" dirty="0"/>
+          </a:p>
+          <a:p>
+            <a:pPr marL="0" indent="0">
+              <a:buNone/>
+            </a:pPr>
+            <a:r>
+              <a:rPr lang="en-US" sz="800" dirty="0">
+                <a:solidFill>
+                  <a:srgbClr val="000000"/>
+                </a:solidFill>
+              </a:rPr>
+              <a:t>
+</a:t>
+            </a:r>
+            <a:endParaRPr lang="en-US" sz="1000" dirty="0"/>
+          </a:p>
+          <a:p>
+            <a:pPr marL="0" indent="0">
+              <a:buNone/>
+            </a:pPr>
+            <a:r>
+              <a:rPr lang="en-US" sz="1000" b="1" dirty="0">
+                <a:solidFill>
+                  <a:srgbClr val="0F172A"/>
+                </a:solidFill>
+              </a:rPr>
+              <a:t>MLflow docs:</a:t>
+            </a:r>
+            <a:endParaRPr lang="en-US" sz="1000" dirty="0"/>
+          </a:p>
+          <a:p>
+            <a:pPr marL="0" indent="0">
+              <a:buNone/>
+            </a:pPr>
+            <a:r>
+              <a:rPr lang="en-US" sz="900" dirty="0">
+                <a:solidFill>
+                  <a:srgbClr val="0EA5E9"/>
+                </a:solidFill>
+                <a:hlinkClick r:id="rId4"/>
+              </a:rPr>
+              <a:t>mlflow.org/docs</a:t>
+            </a:r>
+            <a:endParaRPr lang="en-US" sz="1000" dirty="0"/>
+          </a:p>
+          <a:p>
+            <a:pPr marL="0" indent="0">
+              <a:buNone/>
+            </a:pPr>
+            <a:endParaRPr lang="en-US" sz="1000" dirty="0"/>
+          </a:p>
+        </p:txBody>
+      </p:sp>
     </p:spTree>
     <p:extLst>
       <p:ext uri="{BB962C8B-B14F-4D97-AF65-F5344CB8AC3E}">
-        <p14:creationId xmlns:p14="http://schemas.microsoft.com/office/powerpoint/2010/main" val="2367705957"/>
+        <p14:creationId xmlns:p14="http://schemas.microsoft.com/office/powerpoint/2010/main" val="1545510381"/>
       </p:ext>
     </p:extLst>
   </p:cSld>
@@ -15275,12 +16196,17 @@
           <a:p>
             <a:r>
               <a:rPr lang="fr-FR" dirty="0" err="1"/>
-              <a:t>When</a:t>
+              <a:t>Today’s</a:t>
             </a:r>
             <a:r>
               <a:rPr lang="fr-FR" dirty="0"/>
-              <a:t> to use MLFlow ?</a:t>
-            </a:r>
+              <a:t> </a:t>
+            </a:r>
+            <a:r>
+              <a:rPr lang="fr-FR" dirty="0" err="1"/>
+              <a:t>Lab</a:t>
+            </a:r>
+            <a:endParaRPr lang="fr-FR" dirty="0"/>
           </a:p>
         </p:txBody>
       </p:sp>
@@ -15343,10 +16269,104 @@
       </p:sp>
       <p:sp>
         <p:nvSpPr>
-          <p:cNvPr id="8" name="Shape 6">
+          <p:cNvPr id="3" name="Espace réservé du texte 2">
             <a:extLst>
               <a:ext uri="{FF2B5EF4-FFF2-40B4-BE49-F238E27FC236}">
-                <a16:creationId xmlns:a16="http://schemas.microsoft.com/office/drawing/2014/main" id="{D1127455-F0F5-76B1-21C5-5B32C70D5CE9}"/>
+                <a16:creationId xmlns:a16="http://schemas.microsoft.com/office/drawing/2014/main" id="{084CE7AE-AFA1-CBB6-AB21-37A3D79C9362}"/>
+              </a:ext>
+            </a:extLst>
+          </p:cNvPr>
+          <p:cNvSpPr>
+            <a:spLocks noGrp="1"/>
+          </p:cNvSpPr>
+          <p:nvPr>
+            <p:ph type="body" sz="quarter" idx="14"/>
+          </p:nvPr>
+        </p:nvSpPr>
+        <p:spPr>
+          <a:xfrm>
+            <a:off x="412926" y="1013053"/>
+            <a:ext cx="8352928" cy="830987"/>
+          </a:xfrm>
+        </p:spPr>
+        <p:txBody>
+          <a:bodyPr/>
+          <a:lstStyle/>
+          <a:p>
+            <a:pPr marL="0" indent="0">
+              <a:buNone/>
+            </a:pPr>
+            <a:endParaRPr lang="fr-FR" dirty="0">
+              <a:latin typeface="+mn-lt"/>
+            </a:endParaRPr>
+          </a:p>
+          <a:p>
+            <a:pPr marL="0" indent="0">
+              <a:buNone/>
+            </a:pPr>
+            <a:r>
+              <a:rPr lang="fr-FR" dirty="0" err="1">
+                <a:latin typeface="+mn-lt"/>
+              </a:rPr>
+              <a:t>Completed</a:t>
+            </a:r>
+            <a:r>
+              <a:rPr lang="fr-FR" dirty="0">
+                <a:latin typeface="+mn-lt"/>
+              </a:rPr>
+              <a:t> notebook must </a:t>
+            </a:r>
+            <a:r>
+              <a:rPr lang="fr-FR" dirty="0" err="1">
+                <a:latin typeface="+mn-lt"/>
+              </a:rPr>
+              <a:t>be</a:t>
+            </a:r>
+            <a:r>
+              <a:rPr lang="fr-FR" dirty="0">
+                <a:latin typeface="+mn-lt"/>
+              </a:rPr>
+              <a:t> sent to:           </a:t>
+            </a:r>
+            <a:r>
+              <a:rPr lang="fr-FR" dirty="0">
+                <a:solidFill>
+                  <a:schemeClr val="accent2">
+                    <a:lumMod val="75000"/>
+                  </a:schemeClr>
+                </a:solidFill>
+                <a:hlinkClick r:id="rId2"/>
+              </a:rPr>
+              <a:t>jdiamant280@headmind.com</a:t>
+            </a:r>
+            <a:endParaRPr lang="fr-FR" dirty="0">
+              <a:solidFill>
+                <a:schemeClr val="accent2">
+                  <a:lumMod val="75000"/>
+                </a:schemeClr>
+              </a:solidFill>
+            </a:endParaRPr>
+          </a:p>
+          <a:p>
+            <a:pPr marL="0" indent="0" algn="ctr">
+              <a:buNone/>
+            </a:pPr>
+            <a:endParaRPr lang="fr-FR" dirty="0">
+              <a:solidFill>
+                <a:schemeClr val="accent2">
+                  <a:lumMod val="75000"/>
+                </a:schemeClr>
+              </a:solidFill>
+            </a:endParaRPr>
+          </a:p>
+        </p:txBody>
+      </p:sp>
+      <p:sp>
+        <p:nvSpPr>
+          <p:cNvPr id="17" name="Text 15">
+            <a:extLst>
+              <a:ext uri="{FF2B5EF4-FFF2-40B4-BE49-F238E27FC236}">
+                <a16:creationId xmlns:a16="http://schemas.microsoft.com/office/drawing/2014/main" id="{092ED7DE-D6D9-2CB1-F94A-C0E8A15584DB}"/>
               </a:ext>
             </a:extLst>
           </p:cNvPr>
@@ -15355,93 +16375,8 @@
         </p:nvSpPr>
         <p:spPr>
           <a:xfrm>
-            <a:off x="548640" y="1173480"/>
-            <a:ext cx="8046720" cy="960120"/>
-          </a:xfrm>
-          <a:prstGeom prst="rect">
-            <a:avLst/>
-          </a:prstGeom>
-          <a:solidFill>
-            <a:srgbClr val="FFFFFF"/>
-          </a:solidFill>
-          <a:ln/>
-          <a:effectLst>
-            <a:outerShdw blurRad="101600" dist="38100" dir="8100000" algn="bl" rotWithShape="0">
-              <a:srgbClr val="000000">
-                <a:alpha val="10000"/>
-              </a:srgbClr>
-            </a:outerShdw>
-          </a:effectLst>
-        </p:spPr>
-      </p:sp>
-      <p:sp>
-        <p:nvSpPr>
-          <p:cNvPr id="9" name="Shape 7">
-            <a:extLst>
-              <a:ext uri="{FF2B5EF4-FFF2-40B4-BE49-F238E27FC236}">
-                <a16:creationId xmlns:a16="http://schemas.microsoft.com/office/drawing/2014/main" id="{1BDB26B5-144F-D788-3E32-90BED80C807B}"/>
-              </a:ext>
-            </a:extLst>
-          </p:cNvPr>
-          <p:cNvSpPr/>
-          <p:nvPr/>
-        </p:nvSpPr>
-        <p:spPr>
-          <a:xfrm>
-            <a:off x="548640" y="1173480"/>
-            <a:ext cx="54864" cy="960120"/>
-          </a:xfrm>
-          <a:prstGeom prst="rect">
-            <a:avLst/>
-          </a:prstGeom>
-          <a:solidFill>
-            <a:srgbClr val="0EA5E9"/>
-          </a:solidFill>
-          <a:ln/>
-        </p:spPr>
-      </p:sp>
-      <p:sp>
-        <p:nvSpPr>
-          <p:cNvPr id="10" name="Shape 8">
-            <a:extLst>
-              <a:ext uri="{FF2B5EF4-FFF2-40B4-BE49-F238E27FC236}">
-                <a16:creationId xmlns:a16="http://schemas.microsoft.com/office/drawing/2014/main" id="{FB72635D-F412-6FDF-8722-3421F072F0B8}"/>
-              </a:ext>
-            </a:extLst>
-          </p:cNvPr>
-          <p:cNvSpPr/>
-          <p:nvPr/>
-        </p:nvSpPr>
-        <p:spPr>
-          <a:xfrm>
-            <a:off x="777240" y="1402080"/>
-            <a:ext cx="411480" cy="411480"/>
-          </a:xfrm>
-          <a:prstGeom prst="ellipse">
-            <a:avLst/>
-          </a:prstGeom>
-          <a:solidFill>
-            <a:srgbClr val="0EA5E9"/>
-          </a:solidFill>
-          <a:ln/>
-        </p:spPr>
-      </p:sp>
-      <p:sp>
-        <p:nvSpPr>
-          <p:cNvPr id="11" name="Text 9">
-            <a:extLst>
-              <a:ext uri="{FF2B5EF4-FFF2-40B4-BE49-F238E27FC236}">
-                <a16:creationId xmlns:a16="http://schemas.microsoft.com/office/drawing/2014/main" id="{F3B5F2CE-50FA-8D7D-5536-E74CD6D63FCC}"/>
-              </a:ext>
-            </a:extLst>
-          </p:cNvPr>
-          <p:cNvSpPr/>
-          <p:nvPr/>
-        </p:nvSpPr>
-        <p:spPr>
-          <a:xfrm>
-            <a:off x="777240" y="1402080"/>
-            <a:ext cx="411480" cy="411480"/>
+            <a:off x="548640" y="3292355"/>
+            <a:ext cx="8046720" cy="411480"/>
           </a:xfrm>
           <a:prstGeom prst="rect">
             <a:avLst/>
@@ -15457,1309 +16392,18 @@
               <a:buNone/>
             </a:pPr>
             <a:r>
-              <a:rPr lang="en-US" sz="1600" b="1" dirty="0">
-                <a:solidFill>
-                  <a:srgbClr val="FFFFFF"/>
-                </a:solidFill>
-                <a:ea typeface="Trebuchet MS" pitchFamily="34" charset="-122"/>
-                <a:cs typeface="Trebuchet MS" pitchFamily="34" charset="-120"/>
+              <a:rPr lang="en-US" sz="2100" b="1" dirty="0">
+                <a:ea typeface="+mj-ea"/>
               </a:rPr>
-              <a:t>1</a:t>
-            </a:r>
-            <a:endParaRPr lang="en-US" sz="1600" dirty="0"/>
-          </a:p>
-        </p:txBody>
-      </p:sp>
-      <p:sp>
-        <p:nvSpPr>
-          <p:cNvPr id="12" name="Text 10">
-            <a:extLst>
-              <a:ext uri="{FF2B5EF4-FFF2-40B4-BE49-F238E27FC236}">
-                <a16:creationId xmlns:a16="http://schemas.microsoft.com/office/drawing/2014/main" id="{71C63F7C-C823-D0FF-7294-A61344FE1ABD}"/>
-              </a:ext>
-            </a:extLst>
-          </p:cNvPr>
-          <p:cNvSpPr/>
-          <p:nvPr/>
-        </p:nvSpPr>
-        <p:spPr>
-          <a:xfrm>
-            <a:off x="1371600" y="1283208"/>
-            <a:ext cx="2743200" cy="320040"/>
-          </a:xfrm>
-          <a:prstGeom prst="rect">
-            <a:avLst/>
-          </a:prstGeom>
-          <a:noFill/>
-          <a:ln/>
-        </p:spPr>
-        <p:txBody>
-          <a:bodyPr wrap="square" lIns="0" tIns="0" rIns="0" bIns="0" rtlCol="0" anchor="ctr"/>
-          <a:lstStyle/>
-          <a:p>
-            <a:pPr marL="0" indent="0">
-              <a:buNone/>
-            </a:pPr>
-            <a:r>
-              <a:rPr lang="en-US" sz="1500" b="1" dirty="0">
-                <a:solidFill>
-                  <a:srgbClr val="0F172A"/>
-                </a:solidFill>
-                <a:ea typeface="Trebuchet MS" pitchFamily="34" charset="-122"/>
-                <a:cs typeface="Trebuchet MS" pitchFamily="34" charset="-120"/>
-              </a:rPr>
-              <a:t>Solo projects (local)</a:t>
-            </a:r>
-            <a:endParaRPr lang="en-US" sz="1500" dirty="0"/>
-          </a:p>
-        </p:txBody>
-      </p:sp>
-      <p:sp>
-        <p:nvSpPr>
-          <p:cNvPr id="13" name="Text 11">
-            <a:extLst>
-              <a:ext uri="{FF2B5EF4-FFF2-40B4-BE49-F238E27FC236}">
-                <a16:creationId xmlns:a16="http://schemas.microsoft.com/office/drawing/2014/main" id="{633FDE7A-8BD0-BB46-068A-9873457F828F}"/>
-              </a:ext>
-            </a:extLst>
-          </p:cNvPr>
-          <p:cNvSpPr/>
-          <p:nvPr/>
-        </p:nvSpPr>
-        <p:spPr>
-          <a:xfrm>
-            <a:off x="1371600" y="1612392"/>
-            <a:ext cx="6949440" cy="457200"/>
-          </a:xfrm>
-          <a:prstGeom prst="rect">
-            <a:avLst/>
-          </a:prstGeom>
-          <a:noFill/>
-          <a:ln/>
-        </p:spPr>
-        <p:txBody>
-          <a:bodyPr wrap="square" lIns="0" tIns="0" rIns="0" bIns="0" rtlCol="0" anchor="ctr"/>
-          <a:lstStyle/>
-          <a:p>
-            <a:pPr marL="0" indent="0">
-              <a:buNone/>
-            </a:pPr>
-            <a:r>
-              <a:rPr lang="en-US" sz="1200" dirty="0">
-                <a:solidFill>
-                  <a:srgbClr val="475569"/>
-                </a:solidFill>
-                <a:ea typeface="Calibri" pitchFamily="34" charset="-122"/>
-                <a:cs typeface="Calibri" pitchFamily="34" charset="-120"/>
-              </a:rPr>
-              <a:t>When training one or more ML models on your own machine. MLflow is lightweight — track experiment results without heavy dependencies.</a:t>
-            </a:r>
-            <a:endParaRPr lang="en-US" sz="1200" dirty="0"/>
-          </a:p>
-        </p:txBody>
-      </p:sp>
-      <p:sp>
-        <p:nvSpPr>
-          <p:cNvPr id="14" name="Shape 12">
-            <a:extLst>
-              <a:ext uri="{FF2B5EF4-FFF2-40B4-BE49-F238E27FC236}">
-                <a16:creationId xmlns:a16="http://schemas.microsoft.com/office/drawing/2014/main" id="{0F582C3A-4AA6-490B-2FEA-F595CE85C6BB}"/>
-              </a:ext>
-            </a:extLst>
-          </p:cNvPr>
-          <p:cNvSpPr/>
-          <p:nvPr/>
-        </p:nvSpPr>
-        <p:spPr>
-          <a:xfrm>
-            <a:off x="548640" y="2316480"/>
-            <a:ext cx="8046720" cy="960120"/>
-          </a:xfrm>
-          <a:prstGeom prst="rect">
-            <a:avLst/>
-          </a:prstGeom>
-          <a:solidFill>
-            <a:srgbClr val="FFFFFF"/>
-          </a:solidFill>
-          <a:ln/>
-          <a:effectLst>
-            <a:outerShdw blurRad="101600" dist="38100" dir="8100000" algn="bl" rotWithShape="0">
-              <a:srgbClr val="000000">
-                <a:alpha val="10000"/>
-              </a:srgbClr>
-            </a:outerShdw>
-          </a:effectLst>
-        </p:spPr>
-      </p:sp>
-      <p:sp>
-        <p:nvSpPr>
-          <p:cNvPr id="15" name="Shape 13">
-            <a:extLst>
-              <a:ext uri="{FF2B5EF4-FFF2-40B4-BE49-F238E27FC236}">
-                <a16:creationId xmlns:a16="http://schemas.microsoft.com/office/drawing/2014/main" id="{8F7A1C67-CA40-FC40-4125-9268BBD42A68}"/>
-              </a:ext>
-            </a:extLst>
-          </p:cNvPr>
-          <p:cNvSpPr/>
-          <p:nvPr/>
-        </p:nvSpPr>
-        <p:spPr>
-          <a:xfrm>
-            <a:off x="548640" y="2316480"/>
-            <a:ext cx="54864" cy="960120"/>
-          </a:xfrm>
-          <a:prstGeom prst="rect">
-            <a:avLst/>
-          </a:prstGeom>
-          <a:solidFill>
-            <a:srgbClr val="10B981"/>
-          </a:solidFill>
-          <a:ln/>
-        </p:spPr>
-      </p:sp>
-      <p:sp>
-        <p:nvSpPr>
-          <p:cNvPr id="16" name="Shape 14">
-            <a:extLst>
-              <a:ext uri="{FF2B5EF4-FFF2-40B4-BE49-F238E27FC236}">
-                <a16:creationId xmlns:a16="http://schemas.microsoft.com/office/drawing/2014/main" id="{A91219F6-49D2-0B76-E4DB-C96001EB315E}"/>
-              </a:ext>
-            </a:extLst>
-          </p:cNvPr>
-          <p:cNvSpPr/>
-          <p:nvPr/>
-        </p:nvSpPr>
-        <p:spPr>
-          <a:xfrm>
-            <a:off x="777240" y="2545080"/>
-            <a:ext cx="411480" cy="411480"/>
-          </a:xfrm>
-          <a:prstGeom prst="ellipse">
-            <a:avLst/>
-          </a:prstGeom>
-          <a:solidFill>
-            <a:srgbClr val="10B981"/>
-          </a:solidFill>
-          <a:ln/>
-        </p:spPr>
-      </p:sp>
-      <p:sp>
-        <p:nvSpPr>
-          <p:cNvPr id="17" name="Text 15">
-            <a:extLst>
-              <a:ext uri="{FF2B5EF4-FFF2-40B4-BE49-F238E27FC236}">
-                <a16:creationId xmlns:a16="http://schemas.microsoft.com/office/drawing/2014/main" id="{A7BBD760-1773-5E36-2057-51C384A94DF9}"/>
-              </a:ext>
-            </a:extLst>
-          </p:cNvPr>
-          <p:cNvSpPr/>
-          <p:nvPr/>
-        </p:nvSpPr>
-        <p:spPr>
-          <a:xfrm>
-            <a:off x="777240" y="2545080"/>
-            <a:ext cx="411480" cy="411480"/>
-          </a:xfrm>
-          <a:prstGeom prst="rect">
-            <a:avLst/>
-          </a:prstGeom>
-          <a:noFill/>
-          <a:ln/>
-        </p:spPr>
-        <p:txBody>
-          <a:bodyPr wrap="square" lIns="0" tIns="0" rIns="0" bIns="0" rtlCol="0" anchor="ctr"/>
-          <a:lstStyle/>
-          <a:p>
-            <a:pPr marL="0" indent="0" algn="ctr">
-              <a:buNone/>
-            </a:pPr>
-            <a:r>
-              <a:rPr lang="en-US" sz="1600" b="1" dirty="0">
-                <a:solidFill>
-                  <a:srgbClr val="FFFFFF"/>
-                </a:solidFill>
-                <a:ea typeface="Trebuchet MS" pitchFamily="34" charset="-122"/>
-                <a:cs typeface="Trebuchet MS" pitchFamily="34" charset="-120"/>
-              </a:rPr>
-              <a:t>2</a:t>
-            </a:r>
-            <a:endParaRPr lang="en-US" sz="1600" dirty="0"/>
-          </a:p>
-        </p:txBody>
-      </p:sp>
-      <p:sp>
-        <p:nvSpPr>
-          <p:cNvPr id="18" name="Text 16">
-            <a:extLst>
-              <a:ext uri="{FF2B5EF4-FFF2-40B4-BE49-F238E27FC236}">
-                <a16:creationId xmlns:a16="http://schemas.microsoft.com/office/drawing/2014/main" id="{5D93ABD8-00BF-7AA6-EBFD-F91C10AF67CD}"/>
-              </a:ext>
-            </a:extLst>
-          </p:cNvPr>
-          <p:cNvSpPr/>
-          <p:nvPr/>
-        </p:nvSpPr>
-        <p:spPr>
-          <a:xfrm>
-            <a:off x="1371600" y="2426208"/>
-            <a:ext cx="2743200" cy="320040"/>
-          </a:xfrm>
-          <a:prstGeom prst="rect">
-            <a:avLst/>
-          </a:prstGeom>
-          <a:noFill/>
-          <a:ln/>
-        </p:spPr>
-        <p:txBody>
-          <a:bodyPr wrap="square" lIns="0" tIns="0" rIns="0" bIns="0" rtlCol="0" anchor="ctr"/>
-          <a:lstStyle/>
-          <a:p>
-            <a:pPr marL="0" indent="0">
-              <a:buNone/>
-            </a:pPr>
-            <a:r>
-              <a:rPr lang="en-US" sz="1500" b="1" dirty="0">
-                <a:solidFill>
-                  <a:srgbClr val="0F172A"/>
-                </a:solidFill>
-                <a:ea typeface="Trebuchet MS" pitchFamily="34" charset="-122"/>
-                <a:cs typeface="Trebuchet MS" pitchFamily="34" charset="-120"/>
-              </a:rPr>
-              <a:t>Team projects</a:t>
-            </a:r>
-            <a:endParaRPr lang="en-US" sz="1500" dirty="0"/>
-          </a:p>
-        </p:txBody>
-      </p:sp>
-      <p:sp>
-        <p:nvSpPr>
-          <p:cNvPr id="19" name="Text 17">
-            <a:extLst>
-              <a:ext uri="{FF2B5EF4-FFF2-40B4-BE49-F238E27FC236}">
-                <a16:creationId xmlns:a16="http://schemas.microsoft.com/office/drawing/2014/main" id="{DB68912D-AF72-769B-CBB8-717B5313D398}"/>
-              </a:ext>
-            </a:extLst>
-          </p:cNvPr>
-          <p:cNvSpPr/>
-          <p:nvPr/>
-        </p:nvSpPr>
-        <p:spPr>
-          <a:xfrm>
-            <a:off x="1371600" y="2755392"/>
-            <a:ext cx="6949440" cy="457200"/>
-          </a:xfrm>
-          <a:prstGeom prst="rect">
-            <a:avLst/>
-          </a:prstGeom>
-          <a:noFill/>
-          <a:ln/>
-        </p:spPr>
-        <p:txBody>
-          <a:bodyPr wrap="square" lIns="0" tIns="0" rIns="0" bIns="0" rtlCol="0" anchor="ctr"/>
-          <a:lstStyle/>
-          <a:p>
-            <a:pPr marL="0" indent="0">
-              <a:buNone/>
-            </a:pPr>
-            <a:r>
-              <a:rPr lang="en-US" sz="1200" dirty="0">
-                <a:solidFill>
-                  <a:srgbClr val="475569"/>
-                </a:solidFill>
-                <a:ea typeface="Calibri" pitchFamily="34" charset="-122"/>
-                <a:cs typeface="Calibri" pitchFamily="34" charset="-120"/>
-              </a:rPr>
-              <a:t>Share hyperparameters, metrics, and KPIs on the same model across your team. Everyone sees the same experiment history.</a:t>
-            </a:r>
-            <a:endParaRPr lang="en-US" sz="1200" dirty="0"/>
-          </a:p>
-        </p:txBody>
-      </p:sp>
-      <p:sp>
-        <p:nvSpPr>
-          <p:cNvPr id="20" name="Shape 18">
-            <a:extLst>
-              <a:ext uri="{FF2B5EF4-FFF2-40B4-BE49-F238E27FC236}">
-                <a16:creationId xmlns:a16="http://schemas.microsoft.com/office/drawing/2014/main" id="{902DADD8-0B95-1318-51A0-33AE8B516364}"/>
-              </a:ext>
-            </a:extLst>
-          </p:cNvPr>
-          <p:cNvSpPr/>
-          <p:nvPr/>
-        </p:nvSpPr>
-        <p:spPr>
-          <a:xfrm>
-            <a:off x="548640" y="3459480"/>
-            <a:ext cx="8046720" cy="960120"/>
-          </a:xfrm>
-          <a:prstGeom prst="rect">
-            <a:avLst/>
-          </a:prstGeom>
-          <a:solidFill>
-            <a:srgbClr val="FFFFFF"/>
-          </a:solidFill>
-          <a:ln/>
-          <a:effectLst>
-            <a:outerShdw blurRad="101600" dist="38100" dir="8100000" algn="bl" rotWithShape="0">
-              <a:srgbClr val="000000">
-                <a:alpha val="10000"/>
-              </a:srgbClr>
-            </a:outerShdw>
-          </a:effectLst>
-        </p:spPr>
-      </p:sp>
-      <p:sp>
-        <p:nvSpPr>
-          <p:cNvPr id="21" name="Shape 19">
-            <a:extLst>
-              <a:ext uri="{FF2B5EF4-FFF2-40B4-BE49-F238E27FC236}">
-                <a16:creationId xmlns:a16="http://schemas.microsoft.com/office/drawing/2014/main" id="{EE9760EA-CD46-84BD-47DA-369CB412EFAA}"/>
-              </a:ext>
-            </a:extLst>
-          </p:cNvPr>
-          <p:cNvSpPr/>
-          <p:nvPr/>
-        </p:nvSpPr>
-        <p:spPr>
-          <a:xfrm>
-            <a:off x="548640" y="3459480"/>
-            <a:ext cx="54864" cy="960120"/>
-          </a:xfrm>
-          <a:prstGeom prst="rect">
-            <a:avLst/>
-          </a:prstGeom>
-          <a:solidFill>
-            <a:srgbClr val="8B5CF6"/>
-          </a:solidFill>
-          <a:ln/>
-        </p:spPr>
-      </p:sp>
-      <p:sp>
-        <p:nvSpPr>
-          <p:cNvPr id="22" name="Shape 20">
-            <a:extLst>
-              <a:ext uri="{FF2B5EF4-FFF2-40B4-BE49-F238E27FC236}">
-                <a16:creationId xmlns:a16="http://schemas.microsoft.com/office/drawing/2014/main" id="{B8CFF72A-674E-182A-3AFB-9A96B9743E9F}"/>
-              </a:ext>
-            </a:extLst>
-          </p:cNvPr>
-          <p:cNvSpPr/>
-          <p:nvPr/>
-        </p:nvSpPr>
-        <p:spPr>
-          <a:xfrm>
-            <a:off x="777240" y="3688080"/>
-            <a:ext cx="411480" cy="411480"/>
-          </a:xfrm>
-          <a:prstGeom prst="ellipse">
-            <a:avLst/>
-          </a:prstGeom>
-          <a:solidFill>
-            <a:srgbClr val="8B5CF6"/>
-          </a:solidFill>
-          <a:ln/>
-        </p:spPr>
-      </p:sp>
-      <p:sp>
-        <p:nvSpPr>
-          <p:cNvPr id="23" name="Text 21">
-            <a:extLst>
-              <a:ext uri="{FF2B5EF4-FFF2-40B4-BE49-F238E27FC236}">
-                <a16:creationId xmlns:a16="http://schemas.microsoft.com/office/drawing/2014/main" id="{B86C407A-1D20-BF9F-04B8-98B7667CDA68}"/>
-              </a:ext>
-            </a:extLst>
-          </p:cNvPr>
-          <p:cNvSpPr/>
-          <p:nvPr/>
-        </p:nvSpPr>
-        <p:spPr>
-          <a:xfrm>
-            <a:off x="777240" y="3688080"/>
-            <a:ext cx="411480" cy="411480"/>
-          </a:xfrm>
-          <a:prstGeom prst="rect">
-            <a:avLst/>
-          </a:prstGeom>
-          <a:noFill/>
-          <a:ln/>
-        </p:spPr>
-        <p:txBody>
-          <a:bodyPr wrap="square" lIns="0" tIns="0" rIns="0" bIns="0" rtlCol="0" anchor="ctr"/>
-          <a:lstStyle/>
-          <a:p>
-            <a:pPr marL="0" indent="0" algn="ctr">
-              <a:buNone/>
-            </a:pPr>
-            <a:r>
-              <a:rPr lang="en-US" sz="1600" b="1" dirty="0">
-                <a:solidFill>
-                  <a:srgbClr val="FFFFFF"/>
-                </a:solidFill>
-                <a:ea typeface="Trebuchet MS" pitchFamily="34" charset="-122"/>
-                <a:cs typeface="Trebuchet MS" pitchFamily="34" charset="-120"/>
-              </a:rPr>
-              <a:t>3</a:t>
-            </a:r>
-            <a:endParaRPr lang="en-US" sz="1600" dirty="0"/>
-          </a:p>
-        </p:txBody>
-      </p:sp>
-      <p:sp>
-        <p:nvSpPr>
-          <p:cNvPr id="24" name="Text 22">
-            <a:extLst>
-              <a:ext uri="{FF2B5EF4-FFF2-40B4-BE49-F238E27FC236}">
-                <a16:creationId xmlns:a16="http://schemas.microsoft.com/office/drawing/2014/main" id="{76815E32-86FE-6470-A71B-A57FE7CBDAA3}"/>
-              </a:ext>
-            </a:extLst>
-          </p:cNvPr>
-          <p:cNvSpPr/>
-          <p:nvPr/>
-        </p:nvSpPr>
-        <p:spPr>
-          <a:xfrm>
-            <a:off x="1371600" y="3569208"/>
-            <a:ext cx="4091940" cy="320040"/>
-          </a:xfrm>
-          <a:prstGeom prst="rect">
-            <a:avLst/>
-          </a:prstGeom>
-          <a:noFill/>
-          <a:ln/>
-        </p:spPr>
-        <p:txBody>
-          <a:bodyPr wrap="square" lIns="0" tIns="0" rIns="0" bIns="0" rtlCol="0" anchor="ctr"/>
-          <a:lstStyle/>
-          <a:p>
-            <a:pPr marL="0" indent="0">
-              <a:buNone/>
-            </a:pPr>
-            <a:r>
-              <a:rPr lang="en-US" sz="1500" b="1" dirty="0">
-                <a:solidFill>
-                  <a:srgbClr val="0F172A"/>
-                </a:solidFill>
-                <a:ea typeface="Trebuchet MS" pitchFamily="34" charset="-122"/>
-                <a:cs typeface="Trebuchet MS" pitchFamily="34" charset="-120"/>
-              </a:rPr>
-              <a:t>Production pipelines (cloud / on-premise)</a:t>
-            </a:r>
-            <a:endParaRPr lang="en-US" sz="1500" dirty="0"/>
-          </a:p>
-        </p:txBody>
-      </p:sp>
-      <p:sp>
-        <p:nvSpPr>
-          <p:cNvPr id="25" name="Text 23">
-            <a:extLst>
-              <a:ext uri="{FF2B5EF4-FFF2-40B4-BE49-F238E27FC236}">
-                <a16:creationId xmlns:a16="http://schemas.microsoft.com/office/drawing/2014/main" id="{08032C9C-5FE4-807C-4DB7-7B5BE5CC0826}"/>
-              </a:ext>
-            </a:extLst>
-          </p:cNvPr>
-          <p:cNvSpPr/>
-          <p:nvPr/>
-        </p:nvSpPr>
-        <p:spPr>
-          <a:xfrm>
-            <a:off x="1371600" y="3898392"/>
-            <a:ext cx="6949440" cy="457200"/>
-          </a:xfrm>
-          <a:prstGeom prst="rect">
-            <a:avLst/>
-          </a:prstGeom>
-          <a:noFill/>
-          <a:ln/>
-        </p:spPr>
-        <p:txBody>
-          <a:bodyPr wrap="square" lIns="0" tIns="0" rIns="0" bIns="0" rtlCol="0" anchor="ctr"/>
-          <a:lstStyle/>
-          <a:p>
-            <a:pPr marL="0" indent="0">
-              <a:buNone/>
-            </a:pPr>
-            <a:r>
-              <a:rPr lang="en-US" sz="1200" dirty="0">
-                <a:solidFill>
-                  <a:srgbClr val="475569"/>
-                </a:solidFill>
-                <a:ea typeface="Calibri" pitchFamily="34" charset="-122"/>
-                <a:cs typeface="Calibri" pitchFamily="34" charset="-120"/>
-              </a:rPr>
-              <a:t>MLflow hosts and deploys models. Separating training and deployment pipelines improves maintenance, security, and reliability.</a:t>
-            </a:r>
-            <a:endParaRPr lang="en-US" sz="1200" dirty="0"/>
+              <a:t>Let's get started!</a:t>
+            </a:r>
           </a:p>
         </p:txBody>
       </p:sp>
     </p:spTree>
     <p:extLst>
       <p:ext uri="{BB962C8B-B14F-4D97-AF65-F5344CB8AC3E}">
-        <p14:creationId xmlns:p14="http://schemas.microsoft.com/office/powerpoint/2010/main" val="2297595068"/>
-      </p:ext>
-    </p:extLst>
-  </p:cSld>
-  <p:clrMapOvr>
-    <a:masterClrMapping/>
-  </p:clrMapOvr>
-</p:sld>
-</file>
-
-<file path=ppt/slides/slide19.xml><?xml version="1.0" encoding="utf-8"?>
-<p:sld xmlns:a="http://schemas.openxmlformats.org/drawingml/2006/main" xmlns:r="http://schemas.openxmlformats.org/officeDocument/2006/relationships" xmlns:p="http://schemas.openxmlformats.org/presentationml/2006/main">
-  <p:cSld>
-    <p:spTree>
-      <p:nvGrpSpPr>
-        <p:cNvPr id="1" name=""/>
-        <p:cNvGrpSpPr/>
-        <p:nvPr/>
-      </p:nvGrpSpPr>
-      <p:grpSpPr>
-        <a:xfrm>
-          <a:off x="0" y="0"/>
-          <a:ext cx="0" cy="0"/>
-          <a:chOff x="0" y="0"/>
-          <a:chExt cx="0" cy="0"/>
-        </a:xfrm>
-      </p:grpSpPr>
-      <p:sp>
-        <p:nvSpPr>
-          <p:cNvPr id="2" name="Titre 1"/>
-          <p:cNvSpPr>
-            <a:spLocks noGrp="1"/>
-          </p:cNvSpPr>
-          <p:nvPr>
-            <p:ph type="title"/>
-          </p:nvPr>
-        </p:nvSpPr>
-        <p:spPr/>
-        <p:txBody>
-          <a:bodyPr/>
-          <a:lstStyle/>
-          <a:p>
-            <a:r>
-              <a:rPr lang="fr-FR" dirty="0" err="1"/>
-              <a:t>When</a:t>
-            </a:r>
-            <a:r>
-              <a:rPr lang="fr-FR" dirty="0"/>
-              <a:t> to use MLFlow ?</a:t>
-            </a:r>
-          </a:p>
-        </p:txBody>
-      </p:sp>
-      <p:sp>
-        <p:nvSpPr>
-          <p:cNvPr id="4" name="Espace réservé du numéro de diapositive 3"/>
-          <p:cNvSpPr>
-            <a:spLocks noGrp="1"/>
-          </p:cNvSpPr>
-          <p:nvPr>
-            <p:ph type="sldNum" sz="quarter" idx="4"/>
-          </p:nvPr>
-        </p:nvSpPr>
-        <p:spPr/>
-        <p:txBody>
-          <a:bodyPr/>
-          <a:lstStyle/>
-          <a:p>
-            <a:pPr>
-              <a:defRPr/>
-            </a:pPr>
-            <a:fld id="{F4FEB08F-923E-484A-9FC5-0AA7BDA29BD6}" type="slidenum">
-              <a:rPr lang="fr-FR" smtClean="0"/>
-              <a:pPr>
-                <a:defRPr/>
-              </a:pPr>
-              <a:t>19</a:t>
-            </a:fld>
-            <a:endParaRPr lang="fr-FR" dirty="0"/>
-          </a:p>
-        </p:txBody>
-      </p:sp>
-      <p:sp>
-        <p:nvSpPr>
-          <p:cNvPr id="6" name="Espace réservé du pied de page 4"/>
-          <p:cNvSpPr>
-            <a:spLocks noGrp="1"/>
-          </p:cNvSpPr>
-          <p:nvPr>
-            <p:ph type="ftr" sz="quarter" idx="3"/>
-          </p:nvPr>
-        </p:nvSpPr>
-        <p:spPr>
-          <a:xfrm>
-            <a:off x="383931" y="4805046"/>
-            <a:ext cx="4254012" cy="273844"/>
-          </a:xfrm>
-        </p:spPr>
-        <p:txBody>
-          <a:bodyPr/>
-          <a:lstStyle/>
-          <a:p>
-            <a:r>
-              <a:rPr lang="en-US" dirty="0"/>
-              <a:t>2026 | ©HeadMind Partners AI &amp; Blockchain</a:t>
-            </a:r>
-            <a:endParaRPr lang="fr-FR" dirty="0"/>
-          </a:p>
-        </p:txBody>
-      </p:sp>
-      <p:sp>
-        <p:nvSpPr>
-          <p:cNvPr id="8" name="Shape 6">
-            <a:extLst>
-              <a:ext uri="{FF2B5EF4-FFF2-40B4-BE49-F238E27FC236}">
-                <a16:creationId xmlns:a16="http://schemas.microsoft.com/office/drawing/2014/main" id="{D1127455-F0F5-76B1-21C5-5B32C70D5CE9}"/>
-              </a:ext>
-            </a:extLst>
-          </p:cNvPr>
-          <p:cNvSpPr/>
-          <p:nvPr/>
-        </p:nvSpPr>
-        <p:spPr>
-          <a:xfrm>
-            <a:off x="548640" y="1173480"/>
-            <a:ext cx="8046720" cy="960120"/>
-          </a:xfrm>
-          <a:prstGeom prst="rect">
-            <a:avLst/>
-          </a:prstGeom>
-          <a:solidFill>
-            <a:srgbClr val="FFFFFF"/>
-          </a:solidFill>
-          <a:ln/>
-          <a:effectLst>
-            <a:outerShdw blurRad="101600" dist="38100" dir="8100000" algn="bl" rotWithShape="0">
-              <a:srgbClr val="000000">
-                <a:alpha val="10000"/>
-              </a:srgbClr>
-            </a:outerShdw>
-          </a:effectLst>
-        </p:spPr>
-      </p:sp>
-      <p:sp>
-        <p:nvSpPr>
-          <p:cNvPr id="9" name="Shape 7">
-            <a:extLst>
-              <a:ext uri="{FF2B5EF4-FFF2-40B4-BE49-F238E27FC236}">
-                <a16:creationId xmlns:a16="http://schemas.microsoft.com/office/drawing/2014/main" id="{1BDB26B5-144F-D788-3E32-90BED80C807B}"/>
-              </a:ext>
-            </a:extLst>
-          </p:cNvPr>
-          <p:cNvSpPr/>
-          <p:nvPr/>
-        </p:nvSpPr>
-        <p:spPr>
-          <a:xfrm>
-            <a:off x="548640" y="1173480"/>
-            <a:ext cx="54864" cy="960120"/>
-          </a:xfrm>
-          <a:prstGeom prst="rect">
-            <a:avLst/>
-          </a:prstGeom>
-          <a:solidFill>
-            <a:srgbClr val="0EA5E9"/>
-          </a:solidFill>
-          <a:ln/>
-        </p:spPr>
-      </p:sp>
-      <p:sp>
-        <p:nvSpPr>
-          <p:cNvPr id="10" name="Shape 8">
-            <a:extLst>
-              <a:ext uri="{FF2B5EF4-FFF2-40B4-BE49-F238E27FC236}">
-                <a16:creationId xmlns:a16="http://schemas.microsoft.com/office/drawing/2014/main" id="{FB72635D-F412-6FDF-8722-3421F072F0B8}"/>
-              </a:ext>
-            </a:extLst>
-          </p:cNvPr>
-          <p:cNvSpPr/>
-          <p:nvPr/>
-        </p:nvSpPr>
-        <p:spPr>
-          <a:xfrm>
-            <a:off x="777240" y="1402080"/>
-            <a:ext cx="411480" cy="411480"/>
-          </a:xfrm>
-          <a:prstGeom prst="ellipse">
-            <a:avLst/>
-          </a:prstGeom>
-          <a:solidFill>
-            <a:srgbClr val="0EA5E9"/>
-          </a:solidFill>
-          <a:ln/>
-        </p:spPr>
-      </p:sp>
-      <p:sp>
-        <p:nvSpPr>
-          <p:cNvPr id="11" name="Text 9">
-            <a:extLst>
-              <a:ext uri="{FF2B5EF4-FFF2-40B4-BE49-F238E27FC236}">
-                <a16:creationId xmlns:a16="http://schemas.microsoft.com/office/drawing/2014/main" id="{F3B5F2CE-50FA-8D7D-5536-E74CD6D63FCC}"/>
-              </a:ext>
-            </a:extLst>
-          </p:cNvPr>
-          <p:cNvSpPr/>
-          <p:nvPr/>
-        </p:nvSpPr>
-        <p:spPr>
-          <a:xfrm>
-            <a:off x="777240" y="1402080"/>
-            <a:ext cx="411480" cy="411480"/>
-          </a:xfrm>
-          <a:prstGeom prst="rect">
-            <a:avLst/>
-          </a:prstGeom>
-          <a:noFill/>
-          <a:ln/>
-        </p:spPr>
-        <p:txBody>
-          <a:bodyPr wrap="square" lIns="0" tIns="0" rIns="0" bIns="0" rtlCol="0" anchor="ctr"/>
-          <a:lstStyle/>
-          <a:p>
-            <a:pPr marL="0" indent="0" algn="ctr">
-              <a:buNone/>
-            </a:pPr>
-            <a:r>
-              <a:rPr lang="en-US" sz="1600" b="1" dirty="0">
-                <a:solidFill>
-                  <a:srgbClr val="FFFFFF"/>
-                </a:solidFill>
-                <a:ea typeface="Trebuchet MS" pitchFamily="34" charset="-122"/>
-                <a:cs typeface="Trebuchet MS" pitchFamily="34" charset="-120"/>
-              </a:rPr>
-              <a:t>1</a:t>
-            </a:r>
-            <a:endParaRPr lang="en-US" sz="1600" dirty="0"/>
-          </a:p>
-        </p:txBody>
-      </p:sp>
-      <p:sp>
-        <p:nvSpPr>
-          <p:cNvPr id="12" name="Text 10">
-            <a:extLst>
-              <a:ext uri="{FF2B5EF4-FFF2-40B4-BE49-F238E27FC236}">
-                <a16:creationId xmlns:a16="http://schemas.microsoft.com/office/drawing/2014/main" id="{71C63F7C-C823-D0FF-7294-A61344FE1ABD}"/>
-              </a:ext>
-            </a:extLst>
-          </p:cNvPr>
-          <p:cNvSpPr/>
-          <p:nvPr/>
-        </p:nvSpPr>
-        <p:spPr>
-          <a:xfrm>
-            <a:off x="1371600" y="1283208"/>
-            <a:ext cx="2743200" cy="320040"/>
-          </a:xfrm>
-          <a:prstGeom prst="rect">
-            <a:avLst/>
-          </a:prstGeom>
-          <a:noFill/>
-          <a:ln/>
-        </p:spPr>
-        <p:txBody>
-          <a:bodyPr wrap="square" lIns="0" tIns="0" rIns="0" bIns="0" rtlCol="0" anchor="ctr"/>
-          <a:lstStyle/>
-          <a:p>
-            <a:pPr marL="0" indent="0">
-              <a:buNone/>
-            </a:pPr>
-            <a:r>
-              <a:rPr lang="en-US" sz="1500" b="1" dirty="0">
-                <a:solidFill>
-                  <a:srgbClr val="0F172A"/>
-                </a:solidFill>
-                <a:ea typeface="Trebuchet MS" pitchFamily="34" charset="-122"/>
-                <a:cs typeface="Trebuchet MS" pitchFamily="34" charset="-120"/>
-              </a:rPr>
-              <a:t>Solo projects (local)</a:t>
-            </a:r>
-            <a:endParaRPr lang="en-US" sz="1500" dirty="0"/>
-          </a:p>
-        </p:txBody>
-      </p:sp>
-      <p:sp>
-        <p:nvSpPr>
-          <p:cNvPr id="13" name="Text 11">
-            <a:extLst>
-              <a:ext uri="{FF2B5EF4-FFF2-40B4-BE49-F238E27FC236}">
-                <a16:creationId xmlns:a16="http://schemas.microsoft.com/office/drawing/2014/main" id="{633FDE7A-8BD0-BB46-068A-9873457F828F}"/>
-              </a:ext>
-            </a:extLst>
-          </p:cNvPr>
-          <p:cNvSpPr/>
-          <p:nvPr/>
-        </p:nvSpPr>
-        <p:spPr>
-          <a:xfrm>
-            <a:off x="1371600" y="1612392"/>
-            <a:ext cx="6949440" cy="457200"/>
-          </a:xfrm>
-          <a:prstGeom prst="rect">
-            <a:avLst/>
-          </a:prstGeom>
-          <a:noFill/>
-          <a:ln/>
-        </p:spPr>
-        <p:txBody>
-          <a:bodyPr wrap="square" lIns="0" tIns="0" rIns="0" bIns="0" rtlCol="0" anchor="ctr"/>
-          <a:lstStyle/>
-          <a:p>
-            <a:pPr marL="0" indent="0">
-              <a:buNone/>
-            </a:pPr>
-            <a:r>
-              <a:rPr lang="en-US" sz="1200" dirty="0">
-                <a:solidFill>
-                  <a:srgbClr val="475569"/>
-                </a:solidFill>
-                <a:ea typeface="Calibri" pitchFamily="34" charset="-122"/>
-                <a:cs typeface="Calibri" pitchFamily="34" charset="-120"/>
-              </a:rPr>
-              <a:t>When training one or more ML models on your own machine. MLflow is lightweight — track experiment results without heavy dependencies.</a:t>
-            </a:r>
-            <a:endParaRPr lang="en-US" sz="1200" dirty="0"/>
-          </a:p>
-        </p:txBody>
-      </p:sp>
-      <p:sp>
-        <p:nvSpPr>
-          <p:cNvPr id="14" name="Shape 12">
-            <a:extLst>
-              <a:ext uri="{FF2B5EF4-FFF2-40B4-BE49-F238E27FC236}">
-                <a16:creationId xmlns:a16="http://schemas.microsoft.com/office/drawing/2014/main" id="{0F582C3A-4AA6-490B-2FEA-F595CE85C6BB}"/>
-              </a:ext>
-            </a:extLst>
-          </p:cNvPr>
-          <p:cNvSpPr/>
-          <p:nvPr/>
-        </p:nvSpPr>
-        <p:spPr>
-          <a:xfrm>
-            <a:off x="548640" y="2316480"/>
-            <a:ext cx="8046720" cy="960120"/>
-          </a:xfrm>
-          <a:prstGeom prst="rect">
-            <a:avLst/>
-          </a:prstGeom>
-          <a:solidFill>
-            <a:srgbClr val="FFFFFF"/>
-          </a:solidFill>
-          <a:ln/>
-          <a:effectLst>
-            <a:outerShdw blurRad="101600" dist="38100" dir="8100000" algn="bl" rotWithShape="0">
-              <a:srgbClr val="000000">
-                <a:alpha val="10000"/>
-              </a:srgbClr>
-            </a:outerShdw>
-          </a:effectLst>
-        </p:spPr>
-      </p:sp>
-      <p:sp>
-        <p:nvSpPr>
-          <p:cNvPr id="15" name="Shape 13">
-            <a:extLst>
-              <a:ext uri="{FF2B5EF4-FFF2-40B4-BE49-F238E27FC236}">
-                <a16:creationId xmlns:a16="http://schemas.microsoft.com/office/drawing/2014/main" id="{8F7A1C67-CA40-FC40-4125-9268BBD42A68}"/>
-              </a:ext>
-            </a:extLst>
-          </p:cNvPr>
-          <p:cNvSpPr/>
-          <p:nvPr/>
-        </p:nvSpPr>
-        <p:spPr>
-          <a:xfrm>
-            <a:off x="548640" y="2316480"/>
-            <a:ext cx="54864" cy="960120"/>
-          </a:xfrm>
-          <a:prstGeom prst="rect">
-            <a:avLst/>
-          </a:prstGeom>
-          <a:solidFill>
-            <a:srgbClr val="10B981"/>
-          </a:solidFill>
-          <a:ln/>
-        </p:spPr>
-      </p:sp>
-      <p:sp>
-        <p:nvSpPr>
-          <p:cNvPr id="16" name="Shape 14">
-            <a:extLst>
-              <a:ext uri="{FF2B5EF4-FFF2-40B4-BE49-F238E27FC236}">
-                <a16:creationId xmlns:a16="http://schemas.microsoft.com/office/drawing/2014/main" id="{A91219F6-49D2-0B76-E4DB-C96001EB315E}"/>
-              </a:ext>
-            </a:extLst>
-          </p:cNvPr>
-          <p:cNvSpPr/>
-          <p:nvPr/>
-        </p:nvSpPr>
-        <p:spPr>
-          <a:xfrm>
-            <a:off x="777240" y="2545080"/>
-            <a:ext cx="411480" cy="411480"/>
-          </a:xfrm>
-          <a:prstGeom prst="ellipse">
-            <a:avLst/>
-          </a:prstGeom>
-          <a:solidFill>
-            <a:srgbClr val="10B981"/>
-          </a:solidFill>
-          <a:ln/>
-        </p:spPr>
-      </p:sp>
-      <p:sp>
-        <p:nvSpPr>
-          <p:cNvPr id="17" name="Text 15">
-            <a:extLst>
-              <a:ext uri="{FF2B5EF4-FFF2-40B4-BE49-F238E27FC236}">
-                <a16:creationId xmlns:a16="http://schemas.microsoft.com/office/drawing/2014/main" id="{A7BBD760-1773-5E36-2057-51C384A94DF9}"/>
-              </a:ext>
-            </a:extLst>
-          </p:cNvPr>
-          <p:cNvSpPr/>
-          <p:nvPr/>
-        </p:nvSpPr>
-        <p:spPr>
-          <a:xfrm>
-            <a:off x="777240" y="2545080"/>
-            <a:ext cx="411480" cy="411480"/>
-          </a:xfrm>
-          <a:prstGeom prst="rect">
-            <a:avLst/>
-          </a:prstGeom>
-          <a:noFill/>
-          <a:ln/>
-        </p:spPr>
-        <p:txBody>
-          <a:bodyPr wrap="square" lIns="0" tIns="0" rIns="0" bIns="0" rtlCol="0" anchor="ctr"/>
-          <a:lstStyle/>
-          <a:p>
-            <a:pPr marL="0" indent="0" algn="ctr">
-              <a:buNone/>
-            </a:pPr>
-            <a:r>
-              <a:rPr lang="en-US" sz="1600" b="1" dirty="0">
-                <a:solidFill>
-                  <a:srgbClr val="FFFFFF"/>
-                </a:solidFill>
-                <a:ea typeface="Trebuchet MS" pitchFamily="34" charset="-122"/>
-                <a:cs typeface="Trebuchet MS" pitchFamily="34" charset="-120"/>
-              </a:rPr>
-              <a:t>2</a:t>
-            </a:r>
-            <a:endParaRPr lang="en-US" sz="1600" dirty="0"/>
-          </a:p>
-        </p:txBody>
-      </p:sp>
-      <p:sp>
-        <p:nvSpPr>
-          <p:cNvPr id="18" name="Text 16">
-            <a:extLst>
-              <a:ext uri="{FF2B5EF4-FFF2-40B4-BE49-F238E27FC236}">
-                <a16:creationId xmlns:a16="http://schemas.microsoft.com/office/drawing/2014/main" id="{5D93ABD8-00BF-7AA6-EBFD-F91C10AF67CD}"/>
-              </a:ext>
-            </a:extLst>
-          </p:cNvPr>
-          <p:cNvSpPr/>
-          <p:nvPr/>
-        </p:nvSpPr>
-        <p:spPr>
-          <a:xfrm>
-            <a:off x="1371600" y="2426208"/>
-            <a:ext cx="2743200" cy="320040"/>
-          </a:xfrm>
-          <a:prstGeom prst="rect">
-            <a:avLst/>
-          </a:prstGeom>
-          <a:noFill/>
-          <a:ln/>
-        </p:spPr>
-        <p:txBody>
-          <a:bodyPr wrap="square" lIns="0" tIns="0" rIns="0" bIns="0" rtlCol="0" anchor="ctr"/>
-          <a:lstStyle/>
-          <a:p>
-            <a:pPr marL="0" indent="0">
-              <a:buNone/>
-            </a:pPr>
-            <a:r>
-              <a:rPr lang="en-US" sz="1500" b="1" dirty="0">
-                <a:solidFill>
-                  <a:srgbClr val="0F172A"/>
-                </a:solidFill>
-                <a:ea typeface="Trebuchet MS" pitchFamily="34" charset="-122"/>
-                <a:cs typeface="Trebuchet MS" pitchFamily="34" charset="-120"/>
-              </a:rPr>
-              <a:t>Team projects</a:t>
-            </a:r>
-            <a:endParaRPr lang="en-US" sz="1500" dirty="0"/>
-          </a:p>
-        </p:txBody>
-      </p:sp>
-      <p:sp>
-        <p:nvSpPr>
-          <p:cNvPr id="19" name="Text 17">
-            <a:extLst>
-              <a:ext uri="{FF2B5EF4-FFF2-40B4-BE49-F238E27FC236}">
-                <a16:creationId xmlns:a16="http://schemas.microsoft.com/office/drawing/2014/main" id="{DB68912D-AF72-769B-CBB8-717B5313D398}"/>
-              </a:ext>
-            </a:extLst>
-          </p:cNvPr>
-          <p:cNvSpPr/>
-          <p:nvPr/>
-        </p:nvSpPr>
-        <p:spPr>
-          <a:xfrm>
-            <a:off x="1371600" y="2755392"/>
-            <a:ext cx="6949440" cy="457200"/>
-          </a:xfrm>
-          <a:prstGeom prst="rect">
-            <a:avLst/>
-          </a:prstGeom>
-          <a:noFill/>
-          <a:ln/>
-        </p:spPr>
-        <p:txBody>
-          <a:bodyPr wrap="square" lIns="0" tIns="0" rIns="0" bIns="0" rtlCol="0" anchor="ctr"/>
-          <a:lstStyle/>
-          <a:p>
-            <a:pPr marL="0" indent="0">
-              <a:buNone/>
-            </a:pPr>
-            <a:r>
-              <a:rPr lang="en-US" sz="1200" dirty="0">
-                <a:solidFill>
-                  <a:srgbClr val="475569"/>
-                </a:solidFill>
-                <a:ea typeface="Calibri" pitchFamily="34" charset="-122"/>
-                <a:cs typeface="Calibri" pitchFamily="34" charset="-120"/>
-              </a:rPr>
-              <a:t>Share hyperparameters, metrics, and KPIs on the same model across your team. Everyone sees the same experiment history.</a:t>
-            </a:r>
-            <a:endParaRPr lang="en-US" sz="1200" dirty="0"/>
-          </a:p>
-        </p:txBody>
-      </p:sp>
-      <p:sp>
-        <p:nvSpPr>
-          <p:cNvPr id="20" name="Shape 18">
-            <a:extLst>
-              <a:ext uri="{FF2B5EF4-FFF2-40B4-BE49-F238E27FC236}">
-                <a16:creationId xmlns:a16="http://schemas.microsoft.com/office/drawing/2014/main" id="{902DADD8-0B95-1318-51A0-33AE8B516364}"/>
-              </a:ext>
-            </a:extLst>
-          </p:cNvPr>
-          <p:cNvSpPr/>
-          <p:nvPr/>
-        </p:nvSpPr>
-        <p:spPr>
-          <a:xfrm>
-            <a:off x="548640" y="3459480"/>
-            <a:ext cx="8046720" cy="960120"/>
-          </a:xfrm>
-          <a:prstGeom prst="rect">
-            <a:avLst/>
-          </a:prstGeom>
-          <a:solidFill>
-            <a:srgbClr val="FFFFFF"/>
-          </a:solidFill>
-          <a:ln/>
-          <a:effectLst>
-            <a:outerShdw blurRad="101600" dist="38100" dir="8100000" algn="bl" rotWithShape="0">
-              <a:srgbClr val="000000">
-                <a:alpha val="10000"/>
-              </a:srgbClr>
-            </a:outerShdw>
-          </a:effectLst>
-        </p:spPr>
-      </p:sp>
-      <p:sp>
-        <p:nvSpPr>
-          <p:cNvPr id="21" name="Shape 19">
-            <a:extLst>
-              <a:ext uri="{FF2B5EF4-FFF2-40B4-BE49-F238E27FC236}">
-                <a16:creationId xmlns:a16="http://schemas.microsoft.com/office/drawing/2014/main" id="{EE9760EA-CD46-84BD-47DA-369CB412EFAA}"/>
-              </a:ext>
-            </a:extLst>
-          </p:cNvPr>
-          <p:cNvSpPr/>
-          <p:nvPr/>
-        </p:nvSpPr>
-        <p:spPr>
-          <a:xfrm>
-            <a:off x="548640" y="3459480"/>
-            <a:ext cx="54864" cy="960120"/>
-          </a:xfrm>
-          <a:prstGeom prst="rect">
-            <a:avLst/>
-          </a:prstGeom>
-          <a:solidFill>
-            <a:srgbClr val="8B5CF6"/>
-          </a:solidFill>
-          <a:ln/>
-        </p:spPr>
-      </p:sp>
-      <p:sp>
-        <p:nvSpPr>
-          <p:cNvPr id="22" name="Shape 20">
-            <a:extLst>
-              <a:ext uri="{FF2B5EF4-FFF2-40B4-BE49-F238E27FC236}">
-                <a16:creationId xmlns:a16="http://schemas.microsoft.com/office/drawing/2014/main" id="{B8CFF72A-674E-182A-3AFB-9A96B9743E9F}"/>
-              </a:ext>
-            </a:extLst>
-          </p:cNvPr>
-          <p:cNvSpPr/>
-          <p:nvPr/>
-        </p:nvSpPr>
-        <p:spPr>
-          <a:xfrm>
-            <a:off x="777240" y="3688080"/>
-            <a:ext cx="411480" cy="411480"/>
-          </a:xfrm>
-          <a:prstGeom prst="ellipse">
-            <a:avLst/>
-          </a:prstGeom>
-          <a:solidFill>
-            <a:srgbClr val="8B5CF6"/>
-          </a:solidFill>
-          <a:ln/>
-        </p:spPr>
-      </p:sp>
-      <p:sp>
-        <p:nvSpPr>
-          <p:cNvPr id="23" name="Text 21">
-            <a:extLst>
-              <a:ext uri="{FF2B5EF4-FFF2-40B4-BE49-F238E27FC236}">
-                <a16:creationId xmlns:a16="http://schemas.microsoft.com/office/drawing/2014/main" id="{B86C407A-1D20-BF9F-04B8-98B7667CDA68}"/>
-              </a:ext>
-            </a:extLst>
-          </p:cNvPr>
-          <p:cNvSpPr/>
-          <p:nvPr/>
-        </p:nvSpPr>
-        <p:spPr>
-          <a:xfrm>
-            <a:off x="777240" y="3688080"/>
-            <a:ext cx="411480" cy="411480"/>
-          </a:xfrm>
-          <a:prstGeom prst="rect">
-            <a:avLst/>
-          </a:prstGeom>
-          <a:noFill/>
-          <a:ln/>
-        </p:spPr>
-        <p:txBody>
-          <a:bodyPr wrap="square" lIns="0" tIns="0" rIns="0" bIns="0" rtlCol="0" anchor="ctr"/>
-          <a:lstStyle/>
-          <a:p>
-            <a:pPr marL="0" indent="0" algn="ctr">
-              <a:buNone/>
-            </a:pPr>
-            <a:r>
-              <a:rPr lang="en-US" sz="1600" b="1" dirty="0">
-                <a:solidFill>
-                  <a:srgbClr val="FFFFFF"/>
-                </a:solidFill>
-                <a:ea typeface="Trebuchet MS" pitchFamily="34" charset="-122"/>
-                <a:cs typeface="Trebuchet MS" pitchFamily="34" charset="-120"/>
-              </a:rPr>
-              <a:t>3</a:t>
-            </a:r>
-            <a:endParaRPr lang="en-US" sz="1600" dirty="0"/>
-          </a:p>
-        </p:txBody>
-      </p:sp>
-      <p:sp>
-        <p:nvSpPr>
-          <p:cNvPr id="24" name="Text 22">
-            <a:extLst>
-              <a:ext uri="{FF2B5EF4-FFF2-40B4-BE49-F238E27FC236}">
-                <a16:creationId xmlns:a16="http://schemas.microsoft.com/office/drawing/2014/main" id="{76815E32-86FE-6470-A71B-A57FE7CBDAA3}"/>
-              </a:ext>
-            </a:extLst>
-          </p:cNvPr>
-          <p:cNvSpPr/>
-          <p:nvPr/>
-        </p:nvSpPr>
-        <p:spPr>
-          <a:xfrm>
-            <a:off x="1371600" y="3569208"/>
-            <a:ext cx="4091940" cy="320040"/>
-          </a:xfrm>
-          <a:prstGeom prst="rect">
-            <a:avLst/>
-          </a:prstGeom>
-          <a:noFill/>
-          <a:ln/>
-        </p:spPr>
-        <p:txBody>
-          <a:bodyPr wrap="square" lIns="0" tIns="0" rIns="0" bIns="0" rtlCol="0" anchor="ctr"/>
-          <a:lstStyle/>
-          <a:p>
-            <a:pPr marL="0" indent="0">
-              <a:buNone/>
-            </a:pPr>
-            <a:r>
-              <a:rPr lang="en-US" sz="1500" b="1" dirty="0">
-                <a:solidFill>
-                  <a:srgbClr val="0F172A"/>
-                </a:solidFill>
-                <a:ea typeface="Trebuchet MS" pitchFamily="34" charset="-122"/>
-                <a:cs typeface="Trebuchet MS" pitchFamily="34" charset="-120"/>
-              </a:rPr>
-              <a:t>Production pipelines (cloud / on-premise)</a:t>
-            </a:r>
-            <a:endParaRPr lang="en-US" sz="1500" dirty="0"/>
-          </a:p>
-        </p:txBody>
-      </p:sp>
-      <p:sp>
-        <p:nvSpPr>
-          <p:cNvPr id="25" name="Text 23">
-            <a:extLst>
-              <a:ext uri="{FF2B5EF4-FFF2-40B4-BE49-F238E27FC236}">
-                <a16:creationId xmlns:a16="http://schemas.microsoft.com/office/drawing/2014/main" id="{08032C9C-5FE4-807C-4DB7-7B5BE5CC0826}"/>
-              </a:ext>
-            </a:extLst>
-          </p:cNvPr>
-          <p:cNvSpPr/>
-          <p:nvPr/>
-        </p:nvSpPr>
-        <p:spPr>
-          <a:xfrm>
-            <a:off x="1371600" y="3898392"/>
-            <a:ext cx="6949440" cy="457200"/>
-          </a:xfrm>
-          <a:prstGeom prst="rect">
-            <a:avLst/>
-          </a:prstGeom>
-          <a:noFill/>
-          <a:ln/>
-        </p:spPr>
-        <p:txBody>
-          <a:bodyPr wrap="square" lIns="0" tIns="0" rIns="0" bIns="0" rtlCol="0" anchor="ctr"/>
-          <a:lstStyle/>
-          <a:p>
-            <a:pPr marL="0" indent="0">
-              <a:buNone/>
-            </a:pPr>
-            <a:r>
-              <a:rPr lang="en-US" sz="1200" dirty="0">
-                <a:solidFill>
-                  <a:srgbClr val="475569"/>
-                </a:solidFill>
-                <a:ea typeface="Calibri" pitchFamily="34" charset="-122"/>
-                <a:cs typeface="Calibri" pitchFamily="34" charset="-120"/>
-              </a:rPr>
-              <a:t>MLflow hosts and deploys models. Separating training and deployment pipelines improves maintenance, security, and reliability.</a:t>
-            </a:r>
-            <a:endParaRPr lang="en-US" sz="1200" dirty="0"/>
-          </a:p>
-        </p:txBody>
-      </p:sp>
-    </p:spTree>
-    <p:extLst>
-      <p:ext uri="{BB962C8B-B14F-4D97-AF65-F5344CB8AC3E}">
-        <p14:creationId xmlns:p14="http://schemas.microsoft.com/office/powerpoint/2010/main" val="387132826"/>
+        <p14:creationId xmlns:p14="http://schemas.microsoft.com/office/powerpoint/2010/main" val="127326432"/>
       </p:ext>
     </p:extLst>
   </p:cSld>
@@ -16902,934 +16546,6 @@
     <p:extLst>
       <p:ext uri="{BB962C8B-B14F-4D97-AF65-F5344CB8AC3E}">
         <p14:creationId xmlns:p14="http://schemas.microsoft.com/office/powerpoint/2010/main" val="497739371"/>
-      </p:ext>
-    </p:extLst>
-  </p:cSld>
-  <p:clrMapOvr>
-    <a:masterClrMapping/>
-  </p:clrMapOvr>
-</p:sld>
-</file>
-
-<file path=ppt/slides/slide20.xml><?xml version="1.0" encoding="utf-8"?>
-<p:sld xmlns:a="http://schemas.openxmlformats.org/drawingml/2006/main" xmlns:r="http://schemas.openxmlformats.org/officeDocument/2006/relationships" xmlns:p="http://schemas.openxmlformats.org/presentationml/2006/main">
-  <p:cSld>
-    <p:spTree>
-      <p:nvGrpSpPr>
-        <p:cNvPr id="1" name=""/>
-        <p:cNvGrpSpPr/>
-        <p:nvPr/>
-      </p:nvGrpSpPr>
-      <p:grpSpPr>
-        <a:xfrm>
-          <a:off x="0" y="0"/>
-          <a:ext cx="0" cy="0"/>
-          <a:chOff x="0" y="0"/>
-          <a:chExt cx="0" cy="0"/>
-        </a:xfrm>
-      </p:grpSpPr>
-      <p:sp>
-        <p:nvSpPr>
-          <p:cNvPr id="2" name="Titre 1"/>
-          <p:cNvSpPr>
-            <a:spLocks noGrp="1"/>
-          </p:cNvSpPr>
-          <p:nvPr>
-            <p:ph type="title"/>
-          </p:nvPr>
-        </p:nvSpPr>
-        <p:spPr/>
-        <p:txBody>
-          <a:bodyPr/>
-          <a:lstStyle/>
-          <a:p>
-            <a:r>
-              <a:rPr lang="fr-FR" dirty="0" err="1"/>
-              <a:t>Today’s</a:t>
-            </a:r>
-            <a:r>
-              <a:rPr lang="fr-FR" dirty="0"/>
-              <a:t> </a:t>
-            </a:r>
-            <a:r>
-              <a:rPr lang="fr-FR" dirty="0" err="1"/>
-              <a:t>Lab</a:t>
-            </a:r>
-            <a:r>
-              <a:rPr lang="fr-FR" dirty="0"/>
-              <a:t> &amp; </a:t>
-            </a:r>
-            <a:r>
-              <a:rPr lang="fr-FR" dirty="0" err="1"/>
-              <a:t>Resources</a:t>
-            </a:r>
-            <a:endParaRPr lang="fr-FR" dirty="0"/>
-          </a:p>
-        </p:txBody>
-      </p:sp>
-      <p:sp>
-        <p:nvSpPr>
-          <p:cNvPr id="4" name="Espace réservé du numéro de diapositive 3"/>
-          <p:cNvSpPr>
-            <a:spLocks noGrp="1"/>
-          </p:cNvSpPr>
-          <p:nvPr>
-            <p:ph type="sldNum" sz="quarter" idx="4"/>
-          </p:nvPr>
-        </p:nvSpPr>
-        <p:spPr/>
-        <p:txBody>
-          <a:bodyPr/>
-          <a:lstStyle/>
-          <a:p>
-            <a:pPr>
-              <a:defRPr/>
-            </a:pPr>
-            <a:fld id="{F4FEB08F-923E-484A-9FC5-0AA7BDA29BD6}" type="slidenum">
-              <a:rPr lang="fr-FR" smtClean="0"/>
-              <a:pPr>
-                <a:defRPr/>
-              </a:pPr>
-              <a:t>20</a:t>
-            </a:fld>
-            <a:endParaRPr lang="fr-FR" dirty="0"/>
-          </a:p>
-        </p:txBody>
-      </p:sp>
-      <p:sp>
-        <p:nvSpPr>
-          <p:cNvPr id="6" name="Espace réservé du pied de page 4"/>
-          <p:cNvSpPr>
-            <a:spLocks noGrp="1"/>
-          </p:cNvSpPr>
-          <p:nvPr>
-            <p:ph type="ftr" sz="quarter" idx="3"/>
-          </p:nvPr>
-        </p:nvSpPr>
-        <p:spPr>
-          <a:xfrm>
-            <a:off x="383931" y="4805046"/>
-            <a:ext cx="4254012" cy="273844"/>
-          </a:xfrm>
-        </p:spPr>
-        <p:txBody>
-          <a:bodyPr/>
-          <a:lstStyle/>
-          <a:p>
-            <a:r>
-              <a:rPr lang="en-US" dirty="0"/>
-              <a:t>2026 | ©HeadMind Partners AI &amp; Blockchain</a:t>
-            </a:r>
-            <a:endParaRPr lang="fr-FR" dirty="0"/>
-          </a:p>
-        </p:txBody>
-      </p:sp>
-      <p:sp>
-        <p:nvSpPr>
-          <p:cNvPr id="25" name="Shape 6">
-            <a:extLst>
-              <a:ext uri="{FF2B5EF4-FFF2-40B4-BE49-F238E27FC236}">
-                <a16:creationId xmlns:a16="http://schemas.microsoft.com/office/drawing/2014/main" id="{62627B01-911E-8CEC-547D-2DC483113344}"/>
-              </a:ext>
-            </a:extLst>
-          </p:cNvPr>
-          <p:cNvSpPr/>
-          <p:nvPr/>
-        </p:nvSpPr>
-        <p:spPr>
-          <a:xfrm>
-            <a:off x="548640" y="1234440"/>
-            <a:ext cx="5029200" cy="2412492"/>
-          </a:xfrm>
-          <a:prstGeom prst="rect">
-            <a:avLst/>
-          </a:prstGeom>
-          <a:solidFill>
-            <a:srgbClr val="FFFFFF"/>
-          </a:solidFill>
-          <a:ln/>
-          <a:effectLst>
-            <a:outerShdw blurRad="101600" dist="38100" dir="8100000" algn="bl" rotWithShape="0">
-              <a:srgbClr val="000000">
-                <a:alpha val="10000"/>
-              </a:srgbClr>
-            </a:outerShdw>
-          </a:effectLst>
-        </p:spPr>
-      </p:sp>
-      <p:sp>
-        <p:nvSpPr>
-          <p:cNvPr id="26" name="Shape 7">
-            <a:extLst>
-              <a:ext uri="{FF2B5EF4-FFF2-40B4-BE49-F238E27FC236}">
-                <a16:creationId xmlns:a16="http://schemas.microsoft.com/office/drawing/2014/main" id="{D0B6BC73-6E59-3C4C-A54C-E29BAD27F1A5}"/>
-              </a:ext>
-            </a:extLst>
-          </p:cNvPr>
-          <p:cNvSpPr/>
-          <p:nvPr/>
-        </p:nvSpPr>
-        <p:spPr>
-          <a:xfrm>
-            <a:off x="548640" y="1234440"/>
-            <a:ext cx="54864" cy="2412492"/>
-          </a:xfrm>
-          <a:prstGeom prst="rect">
-            <a:avLst/>
-          </a:prstGeom>
-          <a:solidFill>
-            <a:srgbClr val="0EA5E9"/>
-          </a:solidFill>
-          <a:ln/>
-        </p:spPr>
-      </p:sp>
-      <p:sp>
-        <p:nvSpPr>
-          <p:cNvPr id="27" name="Text 8">
-            <a:extLst>
-              <a:ext uri="{FF2B5EF4-FFF2-40B4-BE49-F238E27FC236}">
-                <a16:creationId xmlns:a16="http://schemas.microsoft.com/office/drawing/2014/main" id="{A76D05D1-5449-30A9-BBB6-251918712253}"/>
-              </a:ext>
-            </a:extLst>
-          </p:cNvPr>
-          <p:cNvSpPr/>
-          <p:nvPr/>
-        </p:nvSpPr>
-        <p:spPr>
-          <a:xfrm>
-            <a:off x="777240" y="1325880"/>
-            <a:ext cx="4572000" cy="365760"/>
-          </a:xfrm>
-          <a:prstGeom prst="rect">
-            <a:avLst/>
-          </a:prstGeom>
-          <a:noFill/>
-          <a:ln/>
-        </p:spPr>
-        <p:txBody>
-          <a:bodyPr wrap="square" lIns="0" tIns="0" rIns="0" bIns="0" rtlCol="0" anchor="ctr"/>
-          <a:lstStyle/>
-          <a:p>
-            <a:pPr marL="0" indent="0">
-              <a:buNone/>
-            </a:pPr>
-            <a:r>
-              <a:rPr lang="en-US" sz="1600" b="1" dirty="0">
-                <a:solidFill>
-                  <a:srgbClr val="0EA5E9"/>
-                </a:solidFill>
-                <a:ea typeface="Trebuchet MS" pitchFamily="34" charset="-122"/>
-                <a:cs typeface="Trebuchet MS" pitchFamily="34" charset="-120"/>
-              </a:rPr>
-              <a:t>Lab 01 — MLflow Experiment Tracking</a:t>
-            </a:r>
-            <a:endParaRPr lang="en-US" sz="1600" dirty="0"/>
-          </a:p>
-        </p:txBody>
-      </p:sp>
-      <p:sp>
-        <p:nvSpPr>
-          <p:cNvPr id="28" name="Text 9">
-            <a:extLst>
-              <a:ext uri="{FF2B5EF4-FFF2-40B4-BE49-F238E27FC236}">
-                <a16:creationId xmlns:a16="http://schemas.microsoft.com/office/drawing/2014/main" id="{19FCB265-E1E7-09AA-5211-7D2B70AD0A2D}"/>
-              </a:ext>
-            </a:extLst>
-          </p:cNvPr>
-          <p:cNvSpPr/>
-          <p:nvPr/>
-        </p:nvSpPr>
-        <p:spPr>
-          <a:xfrm>
-            <a:off x="777240" y="1691640"/>
-            <a:ext cx="4572000" cy="274320"/>
-          </a:xfrm>
-          <a:prstGeom prst="rect">
-            <a:avLst/>
-          </a:prstGeom>
-          <a:noFill/>
-          <a:ln/>
-        </p:spPr>
-        <p:txBody>
-          <a:bodyPr wrap="square" lIns="0" tIns="0" rIns="0" bIns="0" rtlCol="0" anchor="ctr"/>
-          <a:lstStyle/>
-          <a:p>
-            <a:pPr marL="0" indent="0">
-              <a:buNone/>
-            </a:pPr>
-            <a:r>
-              <a:rPr lang="en-US" sz="1100" dirty="0">
-                <a:solidFill>
-                  <a:srgbClr val="94A3B8"/>
-                </a:solidFill>
-                <a:ea typeface="Calibri" pitchFamily="34" charset="-122"/>
-                <a:cs typeface="Calibri" pitchFamily="34" charset="-120"/>
-              </a:rPr>
-              <a:t>~2h30  |  German Credit Risk dataset</a:t>
-            </a:r>
-            <a:endParaRPr lang="en-US" sz="1100" dirty="0"/>
-          </a:p>
-        </p:txBody>
-      </p:sp>
-      <p:sp>
-        <p:nvSpPr>
-          <p:cNvPr id="29" name="Shape 11">
-            <a:extLst>
-              <a:ext uri="{FF2B5EF4-FFF2-40B4-BE49-F238E27FC236}">
-                <a16:creationId xmlns:a16="http://schemas.microsoft.com/office/drawing/2014/main" id="{AD138B40-F698-08D2-C04B-32D3DBC28231}"/>
-              </a:ext>
-            </a:extLst>
-          </p:cNvPr>
-          <p:cNvSpPr/>
-          <p:nvPr/>
-        </p:nvSpPr>
-        <p:spPr>
-          <a:xfrm>
-            <a:off x="5943600" y="1234440"/>
-            <a:ext cx="2743200" cy="2412492"/>
-          </a:xfrm>
-          <a:prstGeom prst="rect">
-            <a:avLst/>
-          </a:prstGeom>
-          <a:solidFill>
-            <a:srgbClr val="FFFFFF"/>
-          </a:solidFill>
-          <a:ln/>
-          <a:effectLst>
-            <a:outerShdw blurRad="101600" dist="38100" dir="8100000" algn="bl" rotWithShape="0">
-              <a:srgbClr val="000000">
-                <a:alpha val="10000"/>
-              </a:srgbClr>
-            </a:outerShdw>
-          </a:effectLst>
-        </p:spPr>
-      </p:sp>
-      <p:sp>
-        <p:nvSpPr>
-          <p:cNvPr id="30" name="Shape 12">
-            <a:extLst>
-              <a:ext uri="{FF2B5EF4-FFF2-40B4-BE49-F238E27FC236}">
-                <a16:creationId xmlns:a16="http://schemas.microsoft.com/office/drawing/2014/main" id="{628CA839-1282-F302-5D78-4C9AE63FB55E}"/>
-              </a:ext>
-            </a:extLst>
-          </p:cNvPr>
-          <p:cNvSpPr/>
-          <p:nvPr/>
-        </p:nvSpPr>
-        <p:spPr>
-          <a:xfrm>
-            <a:off x="5943600" y="1234440"/>
-            <a:ext cx="54864" cy="2412492"/>
-          </a:xfrm>
-          <a:prstGeom prst="rect">
-            <a:avLst/>
-          </a:prstGeom>
-          <a:solidFill>
-            <a:srgbClr val="F59E0B"/>
-          </a:solidFill>
-          <a:ln/>
-        </p:spPr>
-      </p:sp>
-      <p:sp>
-        <p:nvSpPr>
-          <p:cNvPr id="31" name="Text 13">
-            <a:extLst>
-              <a:ext uri="{FF2B5EF4-FFF2-40B4-BE49-F238E27FC236}">
-                <a16:creationId xmlns:a16="http://schemas.microsoft.com/office/drawing/2014/main" id="{EDEB5970-149C-583F-F2FA-D94857ABE3D2}"/>
-              </a:ext>
-            </a:extLst>
-          </p:cNvPr>
-          <p:cNvSpPr/>
-          <p:nvPr/>
-        </p:nvSpPr>
-        <p:spPr>
-          <a:xfrm>
-            <a:off x="6126480" y="1325880"/>
-            <a:ext cx="2377440" cy="365760"/>
-          </a:xfrm>
-          <a:prstGeom prst="rect">
-            <a:avLst/>
-          </a:prstGeom>
-          <a:noFill/>
-          <a:ln/>
-        </p:spPr>
-        <p:txBody>
-          <a:bodyPr wrap="square" lIns="0" tIns="0" rIns="0" bIns="0" rtlCol="0" anchor="ctr"/>
-          <a:lstStyle/>
-          <a:p>
-            <a:pPr marL="0" indent="0">
-              <a:buNone/>
-            </a:pPr>
-            <a:r>
-              <a:rPr lang="en-US" sz="1400" b="1" dirty="0">
-                <a:solidFill>
-                  <a:srgbClr val="F59E0B"/>
-                </a:solidFill>
-                <a:ea typeface="Trebuchet MS" pitchFamily="34" charset="-122"/>
-                <a:cs typeface="Trebuchet MS" pitchFamily="34" charset="-120"/>
-              </a:rPr>
-              <a:t>Resources</a:t>
-            </a:r>
-            <a:endParaRPr lang="en-US" sz="1400" dirty="0"/>
-          </a:p>
-        </p:txBody>
-      </p:sp>
-      <p:sp>
-        <p:nvSpPr>
-          <p:cNvPr id="32" name="Text 10">
-            <a:extLst>
-              <a:ext uri="{FF2B5EF4-FFF2-40B4-BE49-F238E27FC236}">
-                <a16:creationId xmlns:a16="http://schemas.microsoft.com/office/drawing/2014/main" id="{54096B3F-653A-74D1-DF63-A674F6F87645}"/>
-              </a:ext>
-            </a:extLst>
-          </p:cNvPr>
-          <p:cNvSpPr/>
-          <p:nvPr/>
-        </p:nvSpPr>
-        <p:spPr>
-          <a:xfrm>
-            <a:off x="777240" y="2011680"/>
-            <a:ext cx="4572000" cy="1409700"/>
-          </a:xfrm>
-          <a:prstGeom prst="rect">
-            <a:avLst/>
-          </a:prstGeom>
-          <a:noFill/>
-          <a:ln/>
-        </p:spPr>
-        <p:txBody>
-          <a:bodyPr wrap="square" lIns="0" tIns="0" rIns="0" bIns="0" rtlCol="0" anchor="t"/>
-          <a:lstStyle/>
-          <a:p>
-            <a:pPr marL="0" indent="0">
-              <a:buNone/>
-            </a:pPr>
-            <a:r>
-              <a:rPr lang="en-US" sz="1200" b="1" dirty="0">
-                <a:solidFill>
-                  <a:srgbClr val="0F172A"/>
-                </a:solidFill>
-              </a:rPr>
-              <a:t>What you will learn:</a:t>
-            </a:r>
-            <a:endParaRPr lang="en-US" sz="1200" dirty="0"/>
-          </a:p>
-          <a:p>
-            <a:pPr marL="0" indent="0">
-              <a:buNone/>
-            </a:pPr>
-            <a:r>
-              <a:rPr lang="en-US" sz="400" dirty="0">
-                <a:solidFill>
-                  <a:srgbClr val="000000"/>
-                </a:solidFill>
-              </a:rPr>
-              <a:t>
-</a:t>
-            </a:r>
-            <a:endParaRPr lang="en-US" sz="1200" dirty="0"/>
-          </a:p>
-          <a:p>
-            <a:pPr marL="342900" indent="-342900">
-              <a:buSzPct val="100000"/>
-              <a:buChar char="•"/>
-            </a:pPr>
-            <a:r>
-              <a:rPr lang="en-US" sz="1100" dirty="0">
-                <a:solidFill>
-                  <a:srgbClr val="475569"/>
-                </a:solidFill>
-              </a:rPr>
-              <a:t>Launch &amp; connect to an MLflow tracking server</a:t>
-            </a:r>
-            <a:endParaRPr lang="en-US" sz="1200" dirty="0"/>
-          </a:p>
-          <a:p>
-            <a:pPr marL="342900" indent="-342900">
-              <a:buSzPct val="100000"/>
-              <a:buChar char="•"/>
-            </a:pPr>
-            <a:r>
-              <a:rPr lang="en-US" sz="1100" dirty="0">
-                <a:solidFill>
-                  <a:srgbClr val="475569"/>
-                </a:solidFill>
-              </a:rPr>
-              <a:t>Log parameters, metrics, and artifacts</a:t>
-            </a:r>
-            <a:endParaRPr lang="en-US" sz="1200" dirty="0"/>
-          </a:p>
-          <a:p>
-            <a:pPr marL="342900" indent="-342900">
-              <a:buSzPct val="100000"/>
-              <a:buChar char="•"/>
-            </a:pPr>
-            <a:r>
-              <a:rPr lang="en-US" sz="1100" dirty="0">
-                <a:solidFill>
-                  <a:srgbClr val="475569"/>
-                </a:solidFill>
-              </a:rPr>
-              <a:t>Compare runs using the MLflow UI</a:t>
-            </a:r>
-            <a:endParaRPr lang="en-US" sz="1200" dirty="0"/>
-          </a:p>
-          <a:p>
-            <a:pPr marL="342900" indent="-342900">
-              <a:buSzPct val="100000"/>
-              <a:buChar char="•"/>
-            </a:pPr>
-            <a:r>
-              <a:rPr lang="en-US" sz="1100" dirty="0">
-                <a:solidFill>
-                  <a:srgbClr val="475569"/>
-                </a:solidFill>
-              </a:rPr>
-              <a:t>Automate hyperparameter search with Optuna</a:t>
-            </a:r>
-            <a:endParaRPr lang="en-US" sz="1200" dirty="0"/>
-          </a:p>
-          <a:p>
-            <a:pPr marL="342900" indent="-342900">
-              <a:buSzPct val="100000"/>
-              <a:buChar char="•"/>
-            </a:pPr>
-            <a:r>
-              <a:rPr lang="en-US" sz="1100" dirty="0">
-                <a:solidFill>
-                  <a:srgbClr val="475569"/>
-                </a:solidFill>
-              </a:rPr>
-              <a:t>Register and version models in the Model Registry</a:t>
-            </a:r>
-            <a:endParaRPr lang="en-US" sz="1200" dirty="0"/>
-          </a:p>
-          <a:p>
-            <a:pPr marL="342900" indent="-342900">
-              <a:buSzPct val="100000"/>
-              <a:buChar char="•"/>
-            </a:pPr>
-            <a:r>
-              <a:rPr lang="en-US" sz="1100" dirty="0">
-                <a:solidFill>
-                  <a:srgbClr val="475569"/>
-                </a:solidFill>
-              </a:rPr>
-              <a:t>Load a registered model for inference</a:t>
-            </a:r>
-            <a:endParaRPr lang="en-US" sz="1200" dirty="0"/>
-          </a:p>
-        </p:txBody>
-      </p:sp>
-      <p:sp>
-        <p:nvSpPr>
-          <p:cNvPr id="33" name="Text 14">
-            <a:extLst>
-              <a:ext uri="{FF2B5EF4-FFF2-40B4-BE49-F238E27FC236}">
-                <a16:creationId xmlns:a16="http://schemas.microsoft.com/office/drawing/2014/main" id="{F8298D38-ED21-089D-3F9D-DB54A38DF7DC}"/>
-              </a:ext>
-            </a:extLst>
-          </p:cNvPr>
-          <p:cNvSpPr/>
-          <p:nvPr/>
-        </p:nvSpPr>
-        <p:spPr>
-          <a:xfrm>
-            <a:off x="6126480" y="1836420"/>
-            <a:ext cx="2377440" cy="1684020"/>
-          </a:xfrm>
-          <a:prstGeom prst="rect">
-            <a:avLst/>
-          </a:prstGeom>
-          <a:noFill/>
-          <a:ln/>
-        </p:spPr>
-        <p:txBody>
-          <a:bodyPr wrap="square" lIns="0" tIns="0" rIns="0" bIns="0" rtlCol="0" anchor="t"/>
-          <a:lstStyle/>
-          <a:p>
-            <a:pPr marL="0" indent="0">
-              <a:buNone/>
-            </a:pPr>
-            <a:r>
-              <a:rPr lang="en-US" sz="1000" b="1" dirty="0">
-                <a:solidFill>
-                  <a:srgbClr val="0F172A"/>
-                </a:solidFill>
-              </a:rPr>
-              <a:t>Papers:</a:t>
-            </a:r>
-            <a:endParaRPr lang="en-US" sz="1000" dirty="0"/>
-          </a:p>
-          <a:p>
-            <a:pPr marL="0" indent="0">
-              <a:buNone/>
-            </a:pPr>
-            <a:r>
-              <a:rPr lang="en-US" sz="400" dirty="0">
-                <a:solidFill>
-                  <a:srgbClr val="000000"/>
-                </a:solidFill>
-              </a:rPr>
-              <a:t>
-</a:t>
-            </a:r>
-            <a:endParaRPr lang="en-US" sz="1000" dirty="0"/>
-          </a:p>
-          <a:p>
-            <a:pPr marL="0" indent="0">
-              <a:buNone/>
-            </a:pPr>
-            <a:r>
-              <a:rPr lang="en-US" sz="900" dirty="0">
-                <a:solidFill>
-                  <a:srgbClr val="475569"/>
-                </a:solidFill>
-                <a:hlinkClick r:id="rId2"/>
-              </a:rPr>
-              <a:t>Hidden Technical Debt in ML Systems (Google, 2015)</a:t>
-            </a:r>
-            <a:endParaRPr lang="en-US" sz="1000" dirty="0"/>
-          </a:p>
-          <a:p>
-            <a:pPr marL="0" indent="0">
-              <a:buNone/>
-            </a:pPr>
-            <a:r>
-              <a:rPr lang="en-US" sz="400" dirty="0">
-                <a:solidFill>
-                  <a:srgbClr val="000000"/>
-                </a:solidFill>
-              </a:rPr>
-              <a:t>
-</a:t>
-            </a:r>
-            <a:endParaRPr lang="en-US" sz="1000" dirty="0">
-              <a:hlinkClick r:id="rId3"/>
-            </a:endParaRPr>
-          </a:p>
-          <a:p>
-            <a:pPr marL="0" indent="0">
-              <a:buNone/>
-            </a:pPr>
-            <a:r>
-              <a:rPr lang="en-US" sz="900" dirty="0">
-                <a:solidFill>
-                  <a:srgbClr val="475569"/>
-                </a:solidFill>
-                <a:hlinkClick r:id="rId3"/>
-              </a:rPr>
-              <a:t>Build &amp; Deploy GenAI/ML in the Enterprise (Google, 2024)</a:t>
-            </a:r>
-            <a:endParaRPr lang="en-US" sz="1000" dirty="0"/>
-          </a:p>
-          <a:p>
-            <a:pPr marL="0" indent="0">
-              <a:buNone/>
-            </a:pPr>
-            <a:r>
-              <a:rPr lang="en-US" sz="800" dirty="0">
-                <a:solidFill>
-                  <a:srgbClr val="000000"/>
-                </a:solidFill>
-              </a:rPr>
-              <a:t>
-</a:t>
-            </a:r>
-            <a:endParaRPr lang="en-US" sz="1000" dirty="0"/>
-          </a:p>
-          <a:p>
-            <a:pPr marL="0" indent="0">
-              <a:buNone/>
-            </a:pPr>
-            <a:r>
-              <a:rPr lang="en-US" sz="1000" b="1" dirty="0">
-                <a:solidFill>
-                  <a:srgbClr val="0F172A"/>
-                </a:solidFill>
-              </a:rPr>
-              <a:t>MLflow docs:</a:t>
-            </a:r>
-            <a:endParaRPr lang="en-US" sz="1000" dirty="0"/>
-          </a:p>
-          <a:p>
-            <a:pPr marL="0" indent="0">
-              <a:buNone/>
-            </a:pPr>
-            <a:r>
-              <a:rPr lang="en-US" sz="900" dirty="0">
-                <a:solidFill>
-                  <a:srgbClr val="0EA5E9"/>
-                </a:solidFill>
-                <a:hlinkClick r:id="rId4"/>
-              </a:rPr>
-              <a:t>mlflow.org/docs</a:t>
-            </a:r>
-            <a:endParaRPr lang="en-US" sz="1000" dirty="0"/>
-          </a:p>
-          <a:p>
-            <a:pPr marL="0" indent="0">
-              <a:buNone/>
-            </a:pPr>
-            <a:endParaRPr lang="en-US" sz="1000" dirty="0"/>
-          </a:p>
-        </p:txBody>
-      </p:sp>
-    </p:spTree>
-    <p:extLst>
-      <p:ext uri="{BB962C8B-B14F-4D97-AF65-F5344CB8AC3E}">
-        <p14:creationId xmlns:p14="http://schemas.microsoft.com/office/powerpoint/2010/main" val="1545510381"/>
-      </p:ext>
-    </p:extLst>
-  </p:cSld>
-  <p:clrMapOvr>
-    <a:masterClrMapping/>
-  </p:clrMapOvr>
-</p:sld>
-</file>
-
-<file path=ppt/slides/slide21.xml><?xml version="1.0" encoding="utf-8"?>
-<p:sld xmlns:a="http://schemas.openxmlformats.org/drawingml/2006/main" xmlns:r="http://schemas.openxmlformats.org/officeDocument/2006/relationships" xmlns:p="http://schemas.openxmlformats.org/presentationml/2006/main">
-  <p:cSld>
-    <p:spTree>
-      <p:nvGrpSpPr>
-        <p:cNvPr id="1" name=""/>
-        <p:cNvGrpSpPr/>
-        <p:nvPr/>
-      </p:nvGrpSpPr>
-      <p:grpSpPr>
-        <a:xfrm>
-          <a:off x="0" y="0"/>
-          <a:ext cx="0" cy="0"/>
-          <a:chOff x="0" y="0"/>
-          <a:chExt cx="0" cy="0"/>
-        </a:xfrm>
-      </p:grpSpPr>
-      <p:sp>
-        <p:nvSpPr>
-          <p:cNvPr id="2" name="Titre 1"/>
-          <p:cNvSpPr>
-            <a:spLocks noGrp="1"/>
-          </p:cNvSpPr>
-          <p:nvPr>
-            <p:ph type="title"/>
-          </p:nvPr>
-        </p:nvSpPr>
-        <p:spPr/>
-        <p:txBody>
-          <a:bodyPr/>
-          <a:lstStyle/>
-          <a:p>
-            <a:r>
-              <a:rPr lang="fr-FR" dirty="0" err="1"/>
-              <a:t>Today’s</a:t>
-            </a:r>
-            <a:r>
-              <a:rPr lang="fr-FR" dirty="0"/>
-              <a:t> </a:t>
-            </a:r>
-            <a:r>
-              <a:rPr lang="fr-FR" dirty="0" err="1"/>
-              <a:t>Lab</a:t>
-            </a:r>
-            <a:endParaRPr lang="fr-FR" dirty="0"/>
-          </a:p>
-        </p:txBody>
-      </p:sp>
-      <p:sp>
-        <p:nvSpPr>
-          <p:cNvPr id="4" name="Espace réservé du numéro de diapositive 3"/>
-          <p:cNvSpPr>
-            <a:spLocks noGrp="1"/>
-          </p:cNvSpPr>
-          <p:nvPr>
-            <p:ph type="sldNum" sz="quarter" idx="4"/>
-          </p:nvPr>
-        </p:nvSpPr>
-        <p:spPr/>
-        <p:txBody>
-          <a:bodyPr/>
-          <a:lstStyle/>
-          <a:p>
-            <a:pPr>
-              <a:defRPr/>
-            </a:pPr>
-            <a:fld id="{F4FEB08F-923E-484A-9FC5-0AA7BDA29BD6}" type="slidenum">
-              <a:rPr lang="fr-FR" smtClean="0"/>
-              <a:pPr>
-                <a:defRPr/>
-              </a:pPr>
-              <a:t>21</a:t>
-            </a:fld>
-            <a:endParaRPr lang="fr-FR" dirty="0"/>
-          </a:p>
-        </p:txBody>
-      </p:sp>
-      <p:sp>
-        <p:nvSpPr>
-          <p:cNvPr id="6" name="Espace réservé du pied de page 4"/>
-          <p:cNvSpPr>
-            <a:spLocks noGrp="1"/>
-          </p:cNvSpPr>
-          <p:nvPr>
-            <p:ph type="ftr" sz="quarter" idx="3"/>
-          </p:nvPr>
-        </p:nvSpPr>
-        <p:spPr>
-          <a:xfrm>
-            <a:off x="383931" y="4805046"/>
-            <a:ext cx="4254012" cy="273844"/>
-          </a:xfrm>
-        </p:spPr>
-        <p:txBody>
-          <a:bodyPr/>
-          <a:lstStyle/>
-          <a:p>
-            <a:r>
-              <a:rPr lang="en-US" dirty="0"/>
-              <a:t>2026 | ©HeadMind Partners AI &amp; Blockchain</a:t>
-            </a:r>
-            <a:endParaRPr lang="fr-FR" dirty="0"/>
-          </a:p>
-        </p:txBody>
-      </p:sp>
-      <p:sp>
-        <p:nvSpPr>
-          <p:cNvPr id="3" name="Espace réservé du texte 2">
-            <a:extLst>
-              <a:ext uri="{FF2B5EF4-FFF2-40B4-BE49-F238E27FC236}">
-                <a16:creationId xmlns:a16="http://schemas.microsoft.com/office/drawing/2014/main" id="{084CE7AE-AFA1-CBB6-AB21-37A3D79C9362}"/>
-              </a:ext>
-            </a:extLst>
-          </p:cNvPr>
-          <p:cNvSpPr>
-            <a:spLocks noGrp="1"/>
-          </p:cNvSpPr>
-          <p:nvPr>
-            <p:ph type="body" sz="quarter" idx="14"/>
-          </p:nvPr>
-        </p:nvSpPr>
-        <p:spPr>
-          <a:xfrm>
-            <a:off x="412926" y="1013053"/>
-            <a:ext cx="8352928" cy="830987"/>
-          </a:xfrm>
-        </p:spPr>
-        <p:txBody>
-          <a:bodyPr/>
-          <a:lstStyle/>
-          <a:p>
-            <a:pPr marL="0" indent="0">
-              <a:buNone/>
-            </a:pPr>
-            <a:endParaRPr lang="fr-FR" dirty="0">
-              <a:latin typeface="+mn-lt"/>
-            </a:endParaRPr>
-          </a:p>
-          <a:p>
-            <a:pPr marL="0" indent="0">
-              <a:buNone/>
-            </a:pPr>
-            <a:r>
-              <a:rPr lang="fr-FR" dirty="0" err="1">
-                <a:latin typeface="+mn-lt"/>
-              </a:rPr>
-              <a:t>Completed</a:t>
-            </a:r>
-            <a:r>
-              <a:rPr lang="fr-FR" dirty="0">
-                <a:latin typeface="+mn-lt"/>
-              </a:rPr>
-              <a:t> notebook must </a:t>
-            </a:r>
-            <a:r>
-              <a:rPr lang="fr-FR" dirty="0" err="1">
-                <a:latin typeface="+mn-lt"/>
-              </a:rPr>
-              <a:t>be</a:t>
-            </a:r>
-            <a:r>
-              <a:rPr lang="fr-FR" dirty="0">
-                <a:latin typeface="+mn-lt"/>
-              </a:rPr>
-              <a:t> sent to:           </a:t>
-            </a:r>
-            <a:r>
-              <a:rPr lang="fr-FR" dirty="0">
-                <a:solidFill>
-                  <a:schemeClr val="accent2">
-                    <a:lumMod val="75000"/>
-                  </a:schemeClr>
-                </a:solidFill>
-                <a:hlinkClick r:id="rId2"/>
-              </a:rPr>
-              <a:t>jdiamant280@headmind.com</a:t>
-            </a:r>
-            <a:endParaRPr lang="fr-FR" dirty="0">
-              <a:solidFill>
-                <a:schemeClr val="accent2">
-                  <a:lumMod val="75000"/>
-                </a:schemeClr>
-              </a:solidFill>
-            </a:endParaRPr>
-          </a:p>
-          <a:p>
-            <a:pPr marL="0" indent="0" algn="ctr">
-              <a:buNone/>
-            </a:pPr>
-            <a:endParaRPr lang="fr-FR" dirty="0">
-              <a:solidFill>
-                <a:schemeClr val="accent2">
-                  <a:lumMod val="75000"/>
-                </a:schemeClr>
-              </a:solidFill>
-            </a:endParaRPr>
-          </a:p>
-        </p:txBody>
-      </p:sp>
-      <p:sp>
-        <p:nvSpPr>
-          <p:cNvPr id="17" name="Text 15">
-            <a:extLst>
-              <a:ext uri="{FF2B5EF4-FFF2-40B4-BE49-F238E27FC236}">
-                <a16:creationId xmlns:a16="http://schemas.microsoft.com/office/drawing/2014/main" id="{092ED7DE-D6D9-2CB1-F94A-C0E8A15584DB}"/>
-              </a:ext>
-            </a:extLst>
-          </p:cNvPr>
-          <p:cNvSpPr/>
-          <p:nvPr/>
-        </p:nvSpPr>
-        <p:spPr>
-          <a:xfrm>
-            <a:off x="548640" y="3292355"/>
-            <a:ext cx="8046720" cy="411480"/>
-          </a:xfrm>
-          <a:prstGeom prst="rect">
-            <a:avLst/>
-          </a:prstGeom>
-          <a:noFill/>
-          <a:ln/>
-        </p:spPr>
-        <p:txBody>
-          <a:bodyPr wrap="square" lIns="0" tIns="0" rIns="0" bIns="0" rtlCol="0" anchor="ctr"/>
-          <a:lstStyle/>
-          <a:p>
-            <a:pPr marL="0" indent="0" algn="ctr">
-              <a:buNone/>
-            </a:pPr>
-            <a:r>
-              <a:rPr lang="en-US" sz="2100" b="1" dirty="0">
-                <a:ea typeface="+mj-ea"/>
-              </a:rPr>
-              <a:t>Let's get started!</a:t>
-            </a:r>
-          </a:p>
-        </p:txBody>
-      </p:sp>
-    </p:spTree>
-    <p:extLst>
-      <p:ext uri="{BB962C8B-B14F-4D97-AF65-F5344CB8AC3E}">
-        <p14:creationId xmlns:p14="http://schemas.microsoft.com/office/powerpoint/2010/main" val="127326432"/>
       </p:ext>
     </p:extLst>
   </p:cSld>

</xml_diff>